<commit_message>
Thesis-Driven Essay decks: open cleanly in PowerPoint
pptxgenjs 4.0.1 writes an <a:pPr> before every run of a multi-run
paragraph. A paragraph may have only one, first. Google Slides and
LibreOffice quietly use the first; PowerPoint repairs the paragraph and
scrambles its formatting, so highlights and bold landed on the wrong
words. The renderer now keeps the first pPr in each paragraph and drops
the rest, which is what Google Slides already shows, so nothing changes
there.

Images also get real alt text instead of the local file path pptxgenjs
falls back to.

Adds jszip (already installed for pptxgenjs) as a dev dependency for the
deck script and its tests. All seven decks are rebuilt.

Co-Authored-By: Claude Opus 5.5 <noreply@anthropic.com>
Claude-Session: https://claude.ai/code/session_01UdRZiPuGfgyCyhqFn7imqw
</commit_message>
<xml_diff>
--- a/services/web-app/resources/thesis-essay-decks/lesson-1-day-1.pptx
+++ b/services/web-app/resources/thesis-essay-decks/lesson-1-day-1.pptx
@@ -2444,7 +2444,7 @@
       </p:sp>
       <p:pic>
         <p:nvPicPr>
-          <p:cNvPr id="7" name="Image 0" descr="/home/user/yawp/services/web-app/scripts/thesis-essay-decks/assets/icons/lightbulb.png">    </p:cNvPr>
+          <p:cNvPr id="7" name="Image 0" descr="lightbulb icon">    </p:cNvPr>
           <p:cNvPicPr>
             <a:picLocks noChangeAspect="1"/>
           </p:cNvPicPr>
@@ -2493,7 +2493,7 @@
       </p:sp>
       <p:pic>
         <p:nvPicPr>
-          <p:cNvPr id="9" name="Image 1" descr="/home/user/yawp/services/web-app/scripts/thesis-essay-decks/assets/icons/puzzle.png">    </p:cNvPr>
+          <p:cNvPr id="9" name="Image 1" descr="puzzle icon">    </p:cNvPr>
           <p:cNvPicPr>
             <a:picLocks noChangeAspect="1"/>
           </p:cNvPicPr>
@@ -2542,7 +2542,7 @@
       </p:sp>
       <p:pic>
         <p:nvPicPr>
-          <p:cNvPr id="11" name="Image 2" descr="/home/user/yawp/services/web-app/scripts/thesis-essay-decks/assets/icons/thumbs.png">    </p:cNvPr>
+          <p:cNvPr id="11" name="Image 2" descr="thumbs icon">    </p:cNvPr>
           <p:cNvPicPr>
             <a:picLocks noChangeAspect="1"/>
           </p:cNvPicPr>
@@ -3112,7 +3112,7 @@
       </p:sp>
       <p:pic>
         <p:nvPicPr>
-          <p:cNvPr id="5" name="Image 0" descr="/home/user/yawp/services/web-app/scripts/thesis-essay-decks/assets/icons/pencil.png">    </p:cNvPr>
+          <p:cNvPr id="5" name="Image 0" descr="pencil icon">    </p:cNvPr>
           <p:cNvPicPr>
             <a:picLocks noChangeAspect="1"/>
           </p:cNvPicPr>
@@ -3666,9 +3666,6 @@
               </a:rPr>
               <a:t>What is the </a:t>
             </a:r>
-            <a:pPr indent="0" marL="0">
-              <a:buNone/>
-            </a:pPr>
             <a:r>
               <a:rPr lang="en-US" sz="2600" dirty="0">
                 <a:solidFill>
@@ -3874,7 +3871,7 @@
       </p:sp>
       <p:pic>
         <p:nvPicPr>
-          <p:cNvPr id="5" name="Image 0" descr="/home/user/yawp/services/web-app/scripts/thesis-essay-decks/assets/critical-essay-form.png">    </p:cNvPr>
+          <p:cNvPr id="5" name="Image 0" descr="The critical essay form: introduction, body paragraphs and conclusion.">    </p:cNvPr>
           <p:cNvPicPr>
             <a:picLocks noChangeAspect="1"/>
           </p:cNvPicPr>
@@ -4023,9 +4020,6 @@
               </a:rPr>
               <a:t>Thesis statement</a:t>
             </a:r>
-            <a:pPr indent="0" marL="0">
-              <a:buNone/>
-            </a:pPr>
             <a:r>
               <a:rPr lang="en-US" sz="2400" dirty="0">
                 <a:solidFill>
@@ -4347,7 +4341,7 @@
       </p:sp>
       <p:pic>
         <p:nvPicPr>
-          <p:cNvPr id="5" name="Image 0" descr="/home/user/yawp/services/web-app/scripts/thesis-essay-decks/assets/icons/pencil.png">    </p:cNvPr>
+          <p:cNvPr id="5" name="Image 0" descr="pencil icon">    </p:cNvPr>
           <p:cNvPicPr>
             <a:picLocks noChangeAspect="1"/>
           </p:cNvPicPr>
@@ -4454,9 +4448,6 @@
               </a:rPr>
               <a:t>Over the course of our sessions, you will learn how to write a </a:t>
             </a:r>
-            <a:pPr indent="0" marL="0">
-              <a:buNone/>
-            </a:pPr>
             <a:r>
               <a:rPr lang="en-US" sz="2200" dirty="0">
                 <a:solidFill>
@@ -4471,9 +4462,6 @@
               </a:rPr>
               <a:t>thoughtful, original, critical essay</a:t>
             </a:r>
-            <a:pPr indent="0" marL="0">
-              <a:buNone/>
-            </a:pPr>
             <a:r>
               <a:rPr lang="en-US" sz="2200" dirty="0">
                 <a:solidFill>
@@ -5153,7 +5141,7 @@
       </p:sp>
       <p:pic>
         <p:nvPicPr>
-          <p:cNvPr id="5" name="Image 0" descr="/home/user/yawp/services/web-app/scripts/thesis-essay-decks/assets/icons/pencil.png">    </p:cNvPr>
+          <p:cNvPr id="5" name="Image 0" descr="pencil icon">    </p:cNvPr>
           <p:cNvPicPr>
             <a:picLocks noChangeAspect="1"/>
           </p:cNvPicPr>
@@ -5324,9 +5312,6 @@
               </a:rPr>
               <a:t>Open your class in YAWP! and go to its </a:t>
             </a:r>
-            <a:pPr indent="0" marL="0">
-              <a:buNone/>
-            </a:pPr>
             <a:r>
               <a:rPr lang="en-US" sz="2000" dirty="0">
                 <a:solidFill>
@@ -5341,6 +5326,106 @@
               </a:rPr>
               <a:t>Students</a:t>
             </a:r>
+            <a:r>
+              <a:rPr lang="en-US" sz="2000" dirty="0">
+                <a:solidFill>
+                  <a:srgbClr val="3C3828"/>
+                </a:solidFill>
+                <a:latin typeface="Calibri" pitchFamily="34" charset="0"/>
+                <a:ea typeface="Calibri" pitchFamily="34" charset="-122"/>
+                <a:cs typeface="Calibri" pitchFamily="34" charset="-120"/>
+              </a:rPr>
+              <a:t> tab</a:t>
+            </a:r>
+            <a:endParaRPr lang="en-US" sz="2000" dirty="0"/>
+          </a:p>
+        </p:txBody>
+      </p:sp>
+      <p:sp>
+        <p:nvSpPr>
+          <p:cNvPr id="11" name="Shape 8"/>
+          <p:cNvSpPr/>
+          <p:nvPr/>
+        </p:nvSpPr>
+        <p:spPr>
+          <a:xfrm>
+            <a:off x="6324448" y="2075688"/>
+            <a:ext cx="548640" cy="548640"/>
+          </a:xfrm>
+          <a:prstGeom prst="ellipse">
+            <a:avLst/>
+          </a:prstGeom>
+          <a:solidFill>
+            <a:srgbClr val="FFB600"/>
+          </a:solidFill>
+          <a:ln w="12700">
+            <a:solidFill>
+              <a:srgbClr val="FFB600"/>
+            </a:solidFill>
+            <a:prstDash val="solid"/>
+          </a:ln>
+        </p:spPr>
+      </p:sp>
+      <p:sp>
+        <p:nvSpPr>
+          <p:cNvPr id="12" name="Text 9"/>
+          <p:cNvSpPr/>
+          <p:nvPr/>
+        </p:nvSpPr>
+        <p:spPr>
+          <a:xfrm>
+            <a:off x="6324448" y="2075688"/>
+            <a:ext cx="548640" cy="548640"/>
+          </a:xfrm>
+          <a:prstGeom prst="rect">
+            <a:avLst/>
+          </a:prstGeom>
+          <a:noFill/>
+          <a:ln/>
+        </p:spPr>
+        <p:txBody>
+          <a:bodyPr wrap="square" lIns="0" tIns="0" rIns="0" bIns="0" rtlCol="0" anchor="ctr"/>
+          <a:lstStyle/>
+          <a:p>
+            <a:pPr algn="ctr" indent="0" marL="0">
+              <a:buNone/>
+            </a:pPr>
+            <a:r>
+              <a:rPr lang="en-US" sz="2200" b="1" dirty="0">
+                <a:solidFill>
+                  <a:srgbClr val="FFFEFA"/>
+                </a:solidFill>
+                <a:latin typeface="Georgia" pitchFamily="34" charset="0"/>
+                <a:ea typeface="Georgia" pitchFamily="34" charset="-122"/>
+                <a:cs typeface="Georgia" pitchFamily="34" charset="-120"/>
+              </a:rPr>
+              <a:t>2</a:t>
+            </a:r>
+            <a:endParaRPr lang="en-US" sz="2200" dirty="0"/>
+          </a:p>
+        </p:txBody>
+      </p:sp>
+      <p:sp>
+        <p:nvSpPr>
+          <p:cNvPr id="13" name="Text 10"/>
+          <p:cNvSpPr/>
+          <p:nvPr/>
+        </p:nvSpPr>
+        <p:spPr>
+          <a:xfrm>
+            <a:off x="7055968" y="1965960"/>
+            <a:ext cx="4449928" cy="822960"/>
+          </a:xfrm>
+          <a:prstGeom prst="rect">
+            <a:avLst/>
+          </a:prstGeom>
+          <a:noFill/>
+          <a:ln/>
+        </p:spPr>
+        <p:txBody>
+          <a:bodyPr wrap="square" lIns="0" tIns="0" rIns="0" bIns="0" rtlCol="0" anchor="ctr"/>
+          <a:lstStyle/>
+          <a:p>
             <a:pPr indent="0" marL="0">
               <a:buNone/>
             </a:pPr>
@@ -5353,114 +5438,8 @@
                 <a:ea typeface="Calibri" pitchFamily="34" charset="-122"/>
                 <a:cs typeface="Calibri" pitchFamily="34" charset="-120"/>
               </a:rPr>
-              <a:t> tab</a:t>
-            </a:r>
-            <a:endParaRPr lang="en-US" sz="2000" dirty="0"/>
-          </a:p>
-        </p:txBody>
-      </p:sp>
-      <p:sp>
-        <p:nvSpPr>
-          <p:cNvPr id="11" name="Shape 8"/>
-          <p:cNvSpPr/>
-          <p:nvPr/>
-        </p:nvSpPr>
-        <p:spPr>
-          <a:xfrm>
-            <a:off x="6324448" y="2075688"/>
-            <a:ext cx="548640" cy="548640"/>
-          </a:xfrm>
-          <a:prstGeom prst="ellipse">
-            <a:avLst/>
-          </a:prstGeom>
-          <a:solidFill>
-            <a:srgbClr val="FFB600"/>
-          </a:solidFill>
-          <a:ln w="12700">
-            <a:solidFill>
-              <a:srgbClr val="FFB600"/>
-            </a:solidFill>
-            <a:prstDash val="solid"/>
-          </a:ln>
-        </p:spPr>
-      </p:sp>
-      <p:sp>
-        <p:nvSpPr>
-          <p:cNvPr id="12" name="Text 9"/>
-          <p:cNvSpPr/>
-          <p:nvPr/>
-        </p:nvSpPr>
-        <p:spPr>
-          <a:xfrm>
-            <a:off x="6324448" y="2075688"/>
-            <a:ext cx="548640" cy="548640"/>
-          </a:xfrm>
-          <a:prstGeom prst="rect">
-            <a:avLst/>
-          </a:prstGeom>
-          <a:noFill/>
-          <a:ln/>
-        </p:spPr>
-        <p:txBody>
-          <a:bodyPr wrap="square" lIns="0" tIns="0" rIns="0" bIns="0" rtlCol="0" anchor="ctr"/>
-          <a:lstStyle/>
-          <a:p>
-            <a:pPr algn="ctr" indent="0" marL="0">
-              <a:buNone/>
-            </a:pPr>
-            <a:r>
-              <a:rPr lang="en-US" sz="2200" b="1" dirty="0">
-                <a:solidFill>
-                  <a:srgbClr val="FFFEFA"/>
-                </a:solidFill>
-                <a:latin typeface="Georgia" pitchFamily="34" charset="0"/>
-                <a:ea typeface="Georgia" pitchFamily="34" charset="-122"/>
-                <a:cs typeface="Georgia" pitchFamily="34" charset="-120"/>
-              </a:rPr>
-              <a:t>2</a:t>
-            </a:r>
-            <a:endParaRPr lang="en-US" sz="2200" dirty="0"/>
-          </a:p>
-        </p:txBody>
-      </p:sp>
-      <p:sp>
-        <p:nvSpPr>
-          <p:cNvPr id="13" name="Text 10"/>
-          <p:cNvSpPr/>
-          <p:nvPr/>
-        </p:nvSpPr>
-        <p:spPr>
-          <a:xfrm>
-            <a:off x="7055968" y="1965960"/>
-            <a:ext cx="4449928" cy="822960"/>
-          </a:xfrm>
-          <a:prstGeom prst="rect">
-            <a:avLst/>
-          </a:prstGeom>
-          <a:noFill/>
-          <a:ln/>
-        </p:spPr>
-        <p:txBody>
-          <a:bodyPr wrap="square" lIns="0" tIns="0" rIns="0" bIns="0" rtlCol="0" anchor="ctr"/>
-          <a:lstStyle/>
-          <a:p>
-            <a:pPr indent="0" marL="0">
-              <a:buNone/>
-            </a:pPr>
-            <a:r>
-              <a:rPr lang="en-US" sz="2000" dirty="0">
-                <a:solidFill>
-                  <a:srgbClr val="3C3828"/>
-                </a:solidFill>
-                <a:latin typeface="Calibri" pitchFamily="34" charset="0"/>
-                <a:ea typeface="Calibri" pitchFamily="34" charset="-122"/>
-                <a:cs typeface="Calibri" pitchFamily="34" charset="-120"/>
-              </a:rPr>
               <a:t>Copy the </a:t>
             </a:r>
-            <a:pPr indent="0" marL="0">
-              <a:buNone/>
-            </a:pPr>
             <a:r>
               <a:rPr lang="en-US" sz="2000" dirty="0">
                 <a:solidFill>
@@ -5475,6 +5454,106 @@
               </a:rPr>
               <a:t>join link</a:t>
             </a:r>
+            <a:r>
+              <a:rPr lang="en-US" sz="2000" dirty="0">
+                <a:solidFill>
+                  <a:srgbClr val="3C3828"/>
+                </a:solidFill>
+                <a:latin typeface="Calibri" pitchFamily="34" charset="0"/>
+                <a:ea typeface="Calibri" pitchFamily="34" charset="-122"/>
+                <a:cs typeface="Calibri" pitchFamily="34" charset="-120"/>
+              </a:rPr>
+              <a:t>, or put the QR code up on the board</a:t>
+            </a:r>
+            <a:endParaRPr lang="en-US" sz="2000" dirty="0"/>
+          </a:p>
+        </p:txBody>
+      </p:sp>
+      <p:sp>
+        <p:nvSpPr>
+          <p:cNvPr id="14" name="Shape 11"/>
+          <p:cNvSpPr/>
+          <p:nvPr/>
+        </p:nvSpPr>
+        <p:spPr>
+          <a:xfrm>
+            <a:off x="685800" y="2944368"/>
+            <a:ext cx="548640" cy="548640"/>
+          </a:xfrm>
+          <a:prstGeom prst="ellipse">
+            <a:avLst/>
+          </a:prstGeom>
+          <a:solidFill>
+            <a:srgbClr val="FC4540"/>
+          </a:solidFill>
+          <a:ln w="12700">
+            <a:solidFill>
+              <a:srgbClr val="FC4540"/>
+            </a:solidFill>
+            <a:prstDash val="solid"/>
+          </a:ln>
+        </p:spPr>
+      </p:sp>
+      <p:sp>
+        <p:nvSpPr>
+          <p:cNvPr id="15" name="Text 12"/>
+          <p:cNvSpPr/>
+          <p:nvPr/>
+        </p:nvSpPr>
+        <p:spPr>
+          <a:xfrm>
+            <a:off x="685800" y="2944368"/>
+            <a:ext cx="548640" cy="548640"/>
+          </a:xfrm>
+          <a:prstGeom prst="rect">
+            <a:avLst/>
+          </a:prstGeom>
+          <a:noFill/>
+          <a:ln/>
+        </p:spPr>
+        <p:txBody>
+          <a:bodyPr wrap="square" lIns="0" tIns="0" rIns="0" bIns="0" rtlCol="0" anchor="ctr"/>
+          <a:lstStyle/>
+          <a:p>
+            <a:pPr algn="ctr" indent="0" marL="0">
+              <a:buNone/>
+            </a:pPr>
+            <a:r>
+              <a:rPr lang="en-US" sz="2200" b="1" dirty="0">
+                <a:solidFill>
+                  <a:srgbClr val="FFFEFA"/>
+                </a:solidFill>
+                <a:latin typeface="Georgia" pitchFamily="34" charset="0"/>
+                <a:ea typeface="Georgia" pitchFamily="34" charset="-122"/>
+                <a:cs typeface="Georgia" pitchFamily="34" charset="-120"/>
+              </a:rPr>
+              <a:t>3</a:t>
+            </a:r>
+            <a:endParaRPr lang="en-US" sz="2200" dirty="0"/>
+          </a:p>
+        </p:txBody>
+      </p:sp>
+      <p:sp>
+        <p:nvSpPr>
+          <p:cNvPr id="16" name="Text 13"/>
+          <p:cNvSpPr/>
+          <p:nvPr/>
+        </p:nvSpPr>
+        <p:spPr>
+          <a:xfrm>
+            <a:off x="1417320" y="2834640"/>
+            <a:ext cx="4449928" cy="822960"/>
+          </a:xfrm>
+          <a:prstGeom prst="rect">
+            <a:avLst/>
+          </a:prstGeom>
+          <a:noFill/>
+          <a:ln/>
+        </p:spPr>
+        <p:txBody>
+          <a:bodyPr wrap="square" lIns="0" tIns="0" rIns="0" bIns="0" rtlCol="0" anchor="ctr"/>
+          <a:lstStyle/>
+          <a:p>
             <a:pPr indent="0" marL="0">
               <a:buNone/>
             </a:pPr>
@@ -5487,7 +5566,7 @@
                 <a:ea typeface="Calibri" pitchFamily="34" charset="-122"/>
                 <a:cs typeface="Calibri" pitchFamily="34" charset="-120"/>
               </a:rPr>
-              <a:t>, or put the QR code up on the board</a:t>
+              <a:t>Students open it on their device and create an account</a:t>
             </a:r>
             <a:endParaRPr lang="en-US" sz="2000" dirty="0"/>
           </a:p>
@@ -5495,38 +5574,38 @@
       </p:sp>
       <p:sp>
         <p:nvSpPr>
-          <p:cNvPr id="14" name="Shape 11"/>
-          <p:cNvSpPr/>
-          <p:nvPr/>
-        </p:nvSpPr>
-        <p:spPr>
-          <a:xfrm>
-            <a:off x="685800" y="2944368"/>
+          <p:cNvPr id="17" name="Shape 14"/>
+          <p:cNvSpPr/>
+          <p:nvPr/>
+        </p:nvSpPr>
+        <p:spPr>
+          <a:xfrm>
+            <a:off x="6324448" y="2944368"/>
             <a:ext cx="548640" cy="548640"/>
           </a:xfrm>
           <a:prstGeom prst="ellipse">
             <a:avLst/>
           </a:prstGeom>
           <a:solidFill>
-            <a:srgbClr val="FC4540"/>
+            <a:srgbClr val="FF9755"/>
           </a:solidFill>
           <a:ln w="12700">
             <a:solidFill>
-              <a:srgbClr val="FC4540"/>
-            </a:solidFill>
-            <a:prstDash val="solid"/>
-          </a:ln>
-        </p:spPr>
-      </p:sp>
-      <p:sp>
-        <p:nvSpPr>
-          <p:cNvPr id="15" name="Text 12"/>
-          <p:cNvSpPr/>
-          <p:nvPr/>
-        </p:nvSpPr>
-        <p:spPr>
-          <a:xfrm>
-            <a:off x="685800" y="2944368"/>
+              <a:srgbClr val="FF9755"/>
+            </a:solidFill>
+            <a:prstDash val="solid"/>
+          </a:ln>
+        </p:spPr>
+      </p:sp>
+      <p:sp>
+        <p:nvSpPr>
+          <p:cNvPr id="18" name="Text 15"/>
+          <p:cNvSpPr/>
+          <p:nvPr/>
+        </p:nvSpPr>
+        <p:spPr>
+          <a:xfrm>
+            <a:off x="6324448" y="2944368"/>
             <a:ext cx="548640" cy="548640"/>
           </a:xfrm>
           <a:prstGeom prst="rect">
@@ -5551,7 +5630,7 @@
                 <a:ea typeface="Georgia" pitchFamily="34" charset="-122"/>
                 <a:cs typeface="Georgia" pitchFamily="34" charset="-120"/>
               </a:rPr>
-              <a:t>3</a:t>
+              <a:t>4</a:t>
             </a:r>
             <a:endParaRPr lang="en-US" sz="2200" dirty="0"/>
           </a:p>
@@ -5559,13 +5638,13 @@
       </p:sp>
       <p:sp>
         <p:nvSpPr>
-          <p:cNvPr id="16" name="Text 13"/>
-          <p:cNvSpPr/>
-          <p:nvPr/>
-        </p:nvSpPr>
-        <p:spPr>
-          <a:xfrm>
-            <a:off x="1417320" y="2834640"/>
+          <p:cNvPr id="19" name="Text 16"/>
+          <p:cNvSpPr/>
+          <p:nvPr/>
+        </p:nvSpPr>
+        <p:spPr>
+          <a:xfrm>
+            <a:off x="7055968" y="2834640"/>
             <a:ext cx="4449928" cy="822960"/>
           </a:xfrm>
           <a:prstGeom prst="rect">
@@ -5590,114 +5669,8 @@
                 <a:ea typeface="Calibri" pitchFamily="34" charset="-122"/>
                 <a:cs typeface="Calibri" pitchFamily="34" charset="-120"/>
               </a:rPr>
-              <a:t>Students open it on their device and create an account</a:t>
-            </a:r>
-            <a:endParaRPr lang="en-US" sz="2000" dirty="0"/>
-          </a:p>
-        </p:txBody>
-      </p:sp>
-      <p:sp>
-        <p:nvSpPr>
-          <p:cNvPr id="17" name="Shape 14"/>
-          <p:cNvSpPr/>
-          <p:nvPr/>
-        </p:nvSpPr>
-        <p:spPr>
-          <a:xfrm>
-            <a:off x="6324448" y="2944368"/>
-            <a:ext cx="548640" cy="548640"/>
-          </a:xfrm>
-          <a:prstGeom prst="ellipse">
-            <a:avLst/>
-          </a:prstGeom>
-          <a:solidFill>
-            <a:srgbClr val="FF9755"/>
-          </a:solidFill>
-          <a:ln w="12700">
-            <a:solidFill>
-              <a:srgbClr val="FF9755"/>
-            </a:solidFill>
-            <a:prstDash val="solid"/>
-          </a:ln>
-        </p:spPr>
-      </p:sp>
-      <p:sp>
-        <p:nvSpPr>
-          <p:cNvPr id="18" name="Text 15"/>
-          <p:cNvSpPr/>
-          <p:nvPr/>
-        </p:nvSpPr>
-        <p:spPr>
-          <a:xfrm>
-            <a:off x="6324448" y="2944368"/>
-            <a:ext cx="548640" cy="548640"/>
-          </a:xfrm>
-          <a:prstGeom prst="rect">
-            <a:avLst/>
-          </a:prstGeom>
-          <a:noFill/>
-          <a:ln/>
-        </p:spPr>
-        <p:txBody>
-          <a:bodyPr wrap="square" lIns="0" tIns="0" rIns="0" bIns="0" rtlCol="0" anchor="ctr"/>
-          <a:lstStyle/>
-          <a:p>
-            <a:pPr algn="ctr" indent="0" marL="0">
-              <a:buNone/>
-            </a:pPr>
-            <a:r>
-              <a:rPr lang="en-US" sz="2200" b="1" dirty="0">
-                <a:solidFill>
-                  <a:srgbClr val="FFFEFA"/>
-                </a:solidFill>
-                <a:latin typeface="Georgia" pitchFamily="34" charset="0"/>
-                <a:ea typeface="Georgia" pitchFamily="34" charset="-122"/>
-                <a:cs typeface="Georgia" pitchFamily="34" charset="-120"/>
-              </a:rPr>
-              <a:t>4</a:t>
-            </a:r>
-            <a:endParaRPr lang="en-US" sz="2200" dirty="0"/>
-          </a:p>
-        </p:txBody>
-      </p:sp>
-      <p:sp>
-        <p:nvSpPr>
-          <p:cNvPr id="19" name="Text 16"/>
-          <p:cNvSpPr/>
-          <p:nvPr/>
-        </p:nvSpPr>
-        <p:spPr>
-          <a:xfrm>
-            <a:off x="7055968" y="2834640"/>
-            <a:ext cx="4449928" cy="822960"/>
-          </a:xfrm>
-          <a:prstGeom prst="rect">
-            <a:avLst/>
-          </a:prstGeom>
-          <a:noFill/>
-          <a:ln/>
-        </p:spPr>
-        <p:txBody>
-          <a:bodyPr wrap="square" lIns="0" tIns="0" rIns="0" bIns="0" rtlCol="0" anchor="ctr"/>
-          <a:lstStyle/>
-          <a:p>
-            <a:pPr indent="0" marL="0">
-              <a:buNone/>
-            </a:pPr>
-            <a:r>
-              <a:rPr lang="en-US" sz="2000" dirty="0">
-                <a:solidFill>
-                  <a:srgbClr val="3C3828"/>
-                </a:solidFill>
-                <a:latin typeface="Calibri" pitchFamily="34" charset="0"/>
-                <a:ea typeface="Calibri" pitchFamily="34" charset="-122"/>
-                <a:cs typeface="Calibri" pitchFamily="34" charset="-120"/>
-              </a:rPr>
               <a:t>No email needed: just a </a:t>
             </a:r>
-            <a:pPr indent="0" marL="0">
-              <a:buNone/>
-            </a:pPr>
             <a:r>
               <a:rPr lang="en-US" sz="2000" dirty="0">
                 <a:solidFill>
@@ -5712,9 +5685,6 @@
               </a:rPr>
               <a:t>handle</a:t>
             </a:r>
-            <a:pPr indent="0" marL="0">
-              <a:buNone/>
-            </a:pPr>
             <a:r>
               <a:rPr lang="en-US" sz="2000" dirty="0">
                 <a:solidFill>
@@ -5766,7 +5736,7 @@
       </p:sp>
       <p:pic>
         <p:nvPicPr>
-          <p:cNvPr id="21" name="Image 1" descr="/home/user/yawp/services/web-app/scripts/thesis-essay-decks/assets/yawp-join-link-card.png">    </p:cNvPr>
+          <p:cNvPr id="21" name="Image 1" descr="The class's join link and QR code on the Students tab.">    </p:cNvPr>
           <p:cNvPicPr>
             <a:picLocks noChangeAspect="1"/>
           </p:cNvPicPr>
@@ -5975,7 +5945,7 @@
       </p:sp>
       <p:pic>
         <p:nvPicPr>
-          <p:cNvPr id="5" name="Image 0" descr="/home/user/yawp/services/web-app/scripts/thesis-essay-decks/assets/yawp-join-page.png">    </p:cNvPr>
+          <p:cNvPr id="5" name="Image 0" descr="The YAWP! &quot;Create your student account&quot; page.">    </p:cNvPr>
           <p:cNvPicPr>
             <a:picLocks noChangeAspect="1"/>
           </p:cNvPicPr>
@@ -6121,9 +6091,6 @@
               </a:rPr>
               <a:t>Your </a:t>
             </a:r>
-            <a:pPr indent="0" marL="0">
-              <a:buNone/>
-            </a:pPr>
             <a:r>
               <a:rPr lang="en-US" sz="2400" dirty="0">
                 <a:solidFill>
@@ -6138,6 +6105,67 @@
               </a:rPr>
               <a:t>display name</a:t>
             </a:r>
+            <a:r>
+              <a:rPr lang="en-US" sz="2400" dirty="0">
+                <a:solidFill>
+                  <a:srgbClr val="3C3828"/>
+                </a:solidFill>
+                <a:latin typeface="Calibri" pitchFamily="34" charset="0"/>
+                <a:ea typeface="Calibri" pitchFamily="34" charset="-122"/>
+                <a:cs typeface="Calibri" pitchFamily="34" charset="-120"/>
+              </a:rPr>
+              <a:t>: what your teacher sees</a:t>
+            </a:r>
+            <a:endParaRPr lang="en-US" sz="2400" dirty="0"/>
+          </a:p>
+        </p:txBody>
+      </p:sp>
+      <p:sp>
+        <p:nvSpPr>
+          <p:cNvPr id="10" name="Shape 7"/>
+          <p:cNvSpPr/>
+          <p:nvPr/>
+        </p:nvSpPr>
+        <p:spPr>
+          <a:xfrm>
+            <a:off x="3021439" y="4334256"/>
+            <a:ext cx="292608" cy="292608"/>
+          </a:xfrm>
+          <a:prstGeom prst="ellipse">
+            <a:avLst/>
+          </a:prstGeom>
+          <a:solidFill>
+            <a:srgbClr val="FF9755"/>
+          </a:solidFill>
+          <a:ln w="12700">
+            <a:solidFill>
+              <a:srgbClr val="FF9755"/>
+            </a:solidFill>
+            <a:prstDash val="solid"/>
+          </a:ln>
+        </p:spPr>
+      </p:sp>
+      <p:sp>
+        <p:nvSpPr>
+          <p:cNvPr id="11" name="Text 8"/>
+          <p:cNvSpPr/>
+          <p:nvPr/>
+        </p:nvSpPr>
+        <p:spPr>
+          <a:xfrm>
+            <a:off x="3496927" y="4023360"/>
+            <a:ext cx="8008968" cy="914400"/>
+          </a:xfrm>
+          <a:prstGeom prst="rect">
+            <a:avLst/>
+          </a:prstGeom>
+          <a:noFill/>
+          <a:ln/>
+        </p:spPr>
+        <p:txBody>
+          <a:bodyPr wrap="square" lIns="0" tIns="0" rIns="0" bIns="0" rtlCol="0" anchor="ctr"/>
+          <a:lstStyle/>
+          <a:p>
             <a:pPr indent="0" marL="0">
               <a:buNone/>
             </a:pPr>
@@ -6150,75 +6178,8 @@
                 <a:ea typeface="Calibri" pitchFamily="34" charset="-122"/>
                 <a:cs typeface="Calibri" pitchFamily="34" charset="-120"/>
               </a:rPr>
-              <a:t>: what your teacher sees</a:t>
-            </a:r>
-            <a:endParaRPr lang="en-US" sz="2400" dirty="0"/>
-          </a:p>
-        </p:txBody>
-      </p:sp>
-      <p:sp>
-        <p:nvSpPr>
-          <p:cNvPr id="10" name="Shape 7"/>
-          <p:cNvSpPr/>
-          <p:nvPr/>
-        </p:nvSpPr>
-        <p:spPr>
-          <a:xfrm>
-            <a:off x="3021439" y="4334256"/>
-            <a:ext cx="292608" cy="292608"/>
-          </a:xfrm>
-          <a:prstGeom prst="ellipse">
-            <a:avLst/>
-          </a:prstGeom>
-          <a:solidFill>
-            <a:srgbClr val="FF9755"/>
-          </a:solidFill>
-          <a:ln w="12700">
-            <a:solidFill>
-              <a:srgbClr val="FF9755"/>
-            </a:solidFill>
-            <a:prstDash val="solid"/>
-          </a:ln>
-        </p:spPr>
-      </p:sp>
-      <p:sp>
-        <p:nvSpPr>
-          <p:cNvPr id="11" name="Text 8"/>
-          <p:cNvSpPr/>
-          <p:nvPr/>
-        </p:nvSpPr>
-        <p:spPr>
-          <a:xfrm>
-            <a:off x="3496927" y="4023360"/>
-            <a:ext cx="8008968" cy="914400"/>
-          </a:xfrm>
-          <a:prstGeom prst="rect">
-            <a:avLst/>
-          </a:prstGeom>
-          <a:noFill/>
-          <a:ln/>
-        </p:spPr>
-        <p:txBody>
-          <a:bodyPr wrap="square" lIns="0" tIns="0" rIns="0" bIns="0" rtlCol="0" anchor="ctr"/>
-          <a:lstStyle/>
-          <a:p>
-            <a:pPr indent="0" marL="0">
-              <a:buNone/>
-            </a:pPr>
-            <a:r>
-              <a:rPr lang="en-US" sz="2400" dirty="0">
-                <a:solidFill>
-                  <a:srgbClr val="3C3828"/>
-                </a:solidFill>
-                <a:latin typeface="Calibri" pitchFamily="34" charset="0"/>
-                <a:ea typeface="Calibri" pitchFamily="34" charset="-122"/>
-                <a:cs typeface="Calibri" pitchFamily="34" charset="-120"/>
-              </a:rPr>
               <a:t>A </a:t>
             </a:r>
-            <a:pPr indent="0" marL="0">
-              <a:buNone/>
-            </a:pPr>
             <a:r>
               <a:rPr lang="en-US" sz="2400" dirty="0">
                 <a:solidFill>
@@ -6233,6 +6194,67 @@
               </a:rPr>
               <a:t>handle</a:t>
             </a:r>
+            <a:r>
+              <a:rPr lang="en-US" sz="2400" dirty="0">
+                <a:solidFill>
+                  <a:srgbClr val="3C3828"/>
+                </a:solidFill>
+                <a:latin typeface="Calibri" pitchFamily="34" charset="0"/>
+                <a:ea typeface="Calibri" pitchFamily="34" charset="-122"/>
+                <a:cs typeface="Calibri" pitchFamily="34" charset="-120"/>
+              </a:rPr>
+              <a:t>: how you log in</a:t>
+            </a:r>
+            <a:endParaRPr lang="en-US" sz="2400" dirty="0"/>
+          </a:p>
+        </p:txBody>
+      </p:sp>
+      <p:sp>
+        <p:nvSpPr>
+          <p:cNvPr id="12" name="Shape 9"/>
+          <p:cNvSpPr/>
+          <p:nvPr/>
+        </p:nvSpPr>
+        <p:spPr>
+          <a:xfrm>
+            <a:off x="3021439" y="5248656"/>
+            <a:ext cx="292608" cy="292608"/>
+          </a:xfrm>
+          <a:prstGeom prst="ellipse">
+            <a:avLst/>
+          </a:prstGeom>
+          <a:solidFill>
+            <a:srgbClr val="FC4067"/>
+          </a:solidFill>
+          <a:ln w="12700">
+            <a:solidFill>
+              <a:srgbClr val="FC4067"/>
+            </a:solidFill>
+            <a:prstDash val="solid"/>
+          </a:ln>
+        </p:spPr>
+      </p:sp>
+      <p:sp>
+        <p:nvSpPr>
+          <p:cNvPr id="13" name="Text 10"/>
+          <p:cNvSpPr/>
+          <p:nvPr/>
+        </p:nvSpPr>
+        <p:spPr>
+          <a:xfrm>
+            <a:off x="3496927" y="4937760"/>
+            <a:ext cx="8008968" cy="914400"/>
+          </a:xfrm>
+          <a:prstGeom prst="rect">
+            <a:avLst/>
+          </a:prstGeom>
+          <a:noFill/>
+          <a:ln/>
+        </p:spPr>
+        <p:txBody>
+          <a:bodyPr wrap="square" lIns="0" tIns="0" rIns="0" bIns="0" rtlCol="0" anchor="ctr"/>
+          <a:lstStyle/>
+          <a:p>
             <a:pPr indent="0" marL="0">
               <a:buNone/>
             </a:pPr>
@@ -6245,75 +6267,8 @@
                 <a:ea typeface="Calibri" pitchFamily="34" charset="-122"/>
                 <a:cs typeface="Calibri" pitchFamily="34" charset="-120"/>
               </a:rPr>
-              <a:t>: how you log in</a:t>
-            </a:r>
-            <a:endParaRPr lang="en-US" sz="2400" dirty="0"/>
-          </a:p>
-        </p:txBody>
-      </p:sp>
-      <p:sp>
-        <p:nvSpPr>
-          <p:cNvPr id="12" name="Shape 9"/>
-          <p:cNvSpPr/>
-          <p:nvPr/>
-        </p:nvSpPr>
-        <p:spPr>
-          <a:xfrm>
-            <a:off x="3021439" y="5248656"/>
-            <a:ext cx="292608" cy="292608"/>
-          </a:xfrm>
-          <a:prstGeom prst="ellipse">
-            <a:avLst/>
-          </a:prstGeom>
-          <a:solidFill>
-            <a:srgbClr val="FC4067"/>
-          </a:solidFill>
-          <a:ln w="12700">
-            <a:solidFill>
-              <a:srgbClr val="FC4067"/>
-            </a:solidFill>
-            <a:prstDash val="solid"/>
-          </a:ln>
-        </p:spPr>
-      </p:sp>
-      <p:sp>
-        <p:nvSpPr>
-          <p:cNvPr id="13" name="Text 10"/>
-          <p:cNvSpPr/>
-          <p:nvPr/>
-        </p:nvSpPr>
-        <p:spPr>
-          <a:xfrm>
-            <a:off x="3496927" y="4937760"/>
-            <a:ext cx="8008968" cy="914400"/>
-          </a:xfrm>
-          <a:prstGeom prst="rect">
-            <a:avLst/>
-          </a:prstGeom>
-          <a:noFill/>
-          <a:ln/>
-        </p:spPr>
-        <p:txBody>
-          <a:bodyPr wrap="square" lIns="0" tIns="0" rIns="0" bIns="0" rtlCol="0" anchor="ctr"/>
-          <a:lstStyle/>
-          <a:p>
-            <a:pPr indent="0" marL="0">
-              <a:buNone/>
-            </a:pPr>
-            <a:r>
-              <a:rPr lang="en-US" sz="2400" dirty="0">
-                <a:solidFill>
-                  <a:srgbClr val="3C3828"/>
-                </a:solidFill>
-                <a:latin typeface="Calibri" pitchFamily="34" charset="0"/>
-                <a:ea typeface="Calibri" pitchFamily="34" charset="-122"/>
-                <a:cs typeface="Calibri" pitchFamily="34" charset="-120"/>
-              </a:rPr>
               <a:t>A password, twice, then </a:t>
             </a:r>
-            <a:pPr indent="0" marL="0">
-              <a:buNone/>
-            </a:pPr>
             <a:r>
               <a:rPr lang="en-US" sz="2400" dirty="0">
                 <a:solidFill>
@@ -6519,7 +6474,7 @@
       </p:sp>
       <p:pic>
         <p:nvPicPr>
-          <p:cNvPr id="5" name="Image 0" descr="/home/user/yawp/services/web-app/scripts/thesis-essay-decks/assets/yawp-student-dashboard.png">    </p:cNvPr>
+          <p:cNvPr id="5" name="Image 0" descr="The YAWP! student dashboard after joining.">    </p:cNvPr>
           <p:cNvPicPr>
             <a:picLocks noChangeAspect="1"/>
           </p:cNvPicPr>
@@ -6793,9 +6748,6 @@
               </a:rPr>
               <a:t>The </a:t>
             </a:r>
-            <a:pPr indent="0" marL="0">
-              <a:buNone/>
-            </a:pPr>
             <a:r>
               <a:rPr lang="en-US" sz="2000" dirty="0">
                 <a:solidFill>
@@ -6810,9 +6762,6 @@
               </a:rPr>
               <a:t>Tutor</a:t>
             </a:r>
-            <a:pPr indent="0" marL="0">
-              <a:buNone/>
-            </a:pPr>
             <a:r>
               <a:rPr lang="en-US" sz="2000" dirty="0">
                 <a:solidFill>
@@ -7006,7 +6955,7 @@
       </p:sp>
       <p:pic>
         <p:nvPicPr>
-          <p:cNvPr id="5" name="Image 0" descr="/home/user/yawp/services/web-app/scripts/thesis-essay-decks/assets/icons/pencil.png">    </p:cNvPr>
+          <p:cNvPr id="5" name="Image 0" descr="pencil icon">    </p:cNvPr>
           <p:cNvPicPr>
             <a:picLocks noChangeAspect="1"/>
           </p:cNvPicPr>
@@ -7113,9 +7062,6 @@
               </a:rPr>
               <a:t>The rules: the </a:t>
             </a:r>
-            <a:pPr indent="0" marL="0">
-              <a:buNone/>
-            </a:pPr>
             <a:r>
               <a:rPr lang="en-US" sz="2200" dirty="0">
                 <a:solidFill>
@@ -7130,9 +7076,6 @@
               </a:rPr>
               <a:t>truths have to be true,</a:t>
             </a:r>
-            <a:pPr indent="0" marL="0">
-              <a:buNone/>
-            </a:pPr>
             <a:r>
               <a:rPr lang="en-US" sz="2200" dirty="0">
                 <a:solidFill>
@@ -7144,9 +7087,6 @@
               </a:rPr>
               <a:t> and the </a:t>
             </a:r>
-            <a:pPr indent="0" marL="0">
-              <a:buNone/>
-            </a:pPr>
             <a:r>
               <a:rPr lang="en-US" sz="2200" dirty="0">
                 <a:solidFill>
@@ -7161,9 +7101,6 @@
               </a:rPr>
               <a:t>lie has to be believable.</a:t>
             </a:r>
-            <a:pPr indent="0" marL="0">
-              <a:buNone/>
-            </a:pPr>
             <a:r>
               <a:rPr lang="en-US" sz="2200" dirty="0">
                 <a:solidFill>
@@ -7852,7 +7789,7 @@
       </p:sp>
       <p:pic>
         <p:nvPicPr>
-          <p:cNvPr id="5" name="Image 0" descr="/home/user/yawp/services/web-app/scripts/thesis-essay-decks/assets/brian-twins.jpg">    </p:cNvPr>
+          <p:cNvPr id="5" name="Image 0" descr="A childhood photo of Brian.">    </p:cNvPr>
           <p:cNvPicPr>
             <a:picLocks noChangeAspect="1"/>
           </p:cNvPicPr>
@@ -8106,7 +8043,7 @@
       </p:sp>
       <p:pic>
         <p:nvPicPr>
-          <p:cNvPr id="5" name="Image 0" descr="/home/user/yawp/services/web-app/scripts/thesis-essay-decks/assets/brian-1990s.jpg">    </p:cNvPr>
+          <p:cNvPr id="5" name="Image 0" descr="A photo of Brian from the 1990s.">    </p:cNvPr>
           <p:cNvPicPr>
             <a:picLocks noChangeAspect="1"/>
           </p:cNvPicPr>
@@ -8351,7 +8288,7 @@
       </p:sp>
       <p:pic>
         <p:nvPicPr>
-          <p:cNvPr id="5" name="Image 0" descr="/home/user/yawp/services/web-app/scripts/thesis-essay-decks/assets/icons/pencil.png">    </p:cNvPr>
+          <p:cNvPr id="5" name="Image 0" descr="pencil icon">    </p:cNvPr>
           <p:cNvPicPr>
             <a:picLocks noChangeAspect="1"/>
           </p:cNvPicPr>
@@ -8461,12 +8398,6 @@
               </a:rPr>
               <a:t>Write your own. Remember, the truths have to be true, and </a:t>
             </a:r>
-            <a:pPr indent="0" marL="0">
-              <a:lnSpc>
-                <a:spcPct val="115000"/>
-              </a:lnSpc>
-              <a:buNone/>
-            </a:pPr>
             <a:r>
               <a:rPr lang="en-US" sz="4000" dirty="0">
                 <a:solidFill>
@@ -8744,7 +8675,7 @@
       </p:sp>
       <p:pic>
         <p:nvPicPr>
-          <p:cNvPr id="7" name="Image 0" descr="/home/user/yawp/services/web-app/scripts/thesis-essay-decks/assets/icons/lightbulb.png">    </p:cNvPr>
+          <p:cNvPr id="7" name="Image 0" descr="lightbulb icon">    </p:cNvPr>
           <p:cNvPicPr>
             <a:picLocks noChangeAspect="1"/>
           </p:cNvPicPr>
@@ -8793,7 +8724,7 @@
       </p:sp>
       <p:pic>
         <p:nvPicPr>
-          <p:cNvPr id="9" name="Image 1" descr="/home/user/yawp/services/web-app/scripts/thesis-essay-decks/assets/icons/puzzle.png">    </p:cNvPr>
+          <p:cNvPr id="9" name="Image 1" descr="puzzle icon">    </p:cNvPr>
           <p:cNvPicPr>
             <a:picLocks noChangeAspect="1"/>
           </p:cNvPicPr>
@@ -8842,7 +8773,7 @@
       </p:sp>
       <p:pic>
         <p:nvPicPr>
-          <p:cNvPr id="11" name="Image 2" descr="/home/user/yawp/services/web-app/scripts/thesis-essay-decks/assets/icons/thumbs.png">    </p:cNvPr>
+          <p:cNvPr id="11" name="Image 2" descr="thumbs icon">    </p:cNvPr>
           <p:cNvPicPr>
             <a:picLocks noChangeAspect="1"/>
           </p:cNvPicPr>
@@ -9547,7 +9478,7 @@
       </p:sp>
       <p:pic>
         <p:nvPicPr>
-          <p:cNvPr id="5" name="Image 0" descr="/home/user/yawp/services/web-app/scripts/thesis-essay-decks/assets/icons/pencil.png">    </p:cNvPr>
+          <p:cNvPr id="5" name="Image 0" descr="pencil icon">    </p:cNvPr>
           <p:cNvPicPr>
             <a:picLocks noChangeAspect="1"/>
           </p:cNvPicPr>
@@ -9777,9 +9708,6 @@
               </a:rPr>
               <a:t>Because we have </a:t>
             </a:r>
-            <a:pPr indent="0" marL="0">
-              <a:buNone/>
-            </a:pPr>
             <a:r>
               <a:rPr lang="en-US" sz="2100" dirty="0">
                 <a:solidFill>
@@ -9794,9 +9722,6 @@
               </a:rPr>
               <a:t>things to say!</a:t>
             </a:r>
-            <a:pPr indent="0" marL="0">
-              <a:buNone/>
-            </a:pPr>
             <a:r>
               <a:rPr lang="en-US" sz="2100" dirty="0">
                 <a:solidFill>
@@ -9970,9 +9895,6 @@
               </a:rPr>
               <a:t>Because writing is one of the most effective ways of </a:t>
             </a:r>
-            <a:pPr indent="0" marL="0">
-              <a:buNone/>
-            </a:pPr>
             <a:r>
               <a:rPr lang="en-US" sz="2100" dirty="0">
                 <a:solidFill>
@@ -9987,9 +9909,6 @@
               </a:rPr>
               <a:t>expressing ourselves.</a:t>
             </a:r>
-            <a:pPr indent="0" marL="0">
-              <a:buNone/>
-            </a:pPr>
             <a:r>
               <a:rPr lang="en-US" sz="2100" dirty="0">
                 <a:solidFill>
@@ -10163,9 +10082,6 @@
               </a:rPr>
               <a:t>Because </a:t>
             </a:r>
-            <a:pPr indent="0" marL="0">
-              <a:buNone/>
-            </a:pPr>
             <a:r>
               <a:rPr lang="en-US" sz="2100" dirty="0">
                 <a:solidFill>
@@ -10443,7 +10359,7 @@
       </p:sp>
       <p:pic>
         <p:nvPicPr>
-          <p:cNvPr id="7" name="Image 0" descr="/home/user/yawp/services/web-app/scripts/thesis-essay-decks/assets/icons/lightbulb.png">    </p:cNvPr>
+          <p:cNvPr id="7" name="Image 0" descr="lightbulb icon">    </p:cNvPr>
           <p:cNvPicPr>
             <a:picLocks noChangeAspect="1"/>
           </p:cNvPicPr>
@@ -10492,7 +10408,7 @@
       </p:sp>
       <p:pic>
         <p:nvPicPr>
-          <p:cNvPr id="9" name="Image 1" descr="/home/user/yawp/services/web-app/scripts/thesis-essay-decks/assets/icons/puzzle.png">    </p:cNvPr>
+          <p:cNvPr id="9" name="Image 1" descr="puzzle icon">    </p:cNvPr>
           <p:cNvPicPr>
             <a:picLocks noChangeAspect="1"/>
           </p:cNvPicPr>
@@ -10541,7 +10457,7 @@
       </p:sp>
       <p:pic>
         <p:nvPicPr>
-          <p:cNvPr id="11" name="Image 2" descr="/home/user/yawp/services/web-app/scripts/thesis-essay-decks/assets/icons/thumbs.png">    </p:cNvPr>
+          <p:cNvPr id="11" name="Image 2" descr="thumbs icon">    </p:cNvPr>
           <p:cNvPicPr>
             <a:picLocks noChangeAspect="1"/>
           </p:cNvPicPr>

</xml_diff>

<commit_message>
Rebuild thesis essay decks, lesson plans, handouts and previews
Co-Authored-By: Claude Opus 5.5 <noreply@anthropic.com>
Claude-Session: https://claude.ai/code/session_01HgFafEmDLUVGrdUbUDDMY7
</commit_message>
<xml_diff>
--- a/services/web-app/resources/thesis-essay-decks/lesson-1-day-1.pptx
+++ b/services/web-app/resources/thesis-essay-decks/lesson-1-day-1.pptx
@@ -20,9 +20,10 @@
     <p:sldId id="268" r:id="rId14"/>
     <p:sldId id="269" r:id="rId15"/>
     <p:sldId id="270" r:id="rId16"/>
+    <p:sldId id="271" r:id="rId17"/>
   </p:sldIdLst>
   <p:notesMasterIdLst>
-    <p:notesMasterId r:id="rId17"/>
+    <p:notesMasterId r:id="rId18"/>
   </p:notesMasterIdLst>
   <p:sldSz cx="12191695" cy="6858000"/>
   <p:notesSz cx="6858000" cy="12191695"/>
@@ -1086,6 +1087,94 @@
 </p:notes>
 </file>
 
+<file path=ppt/notesSlides/notesSlide16.xml><?xml version="1.0" encoding="utf-8"?>
+<p:notes xmlns:a="http://schemas.openxmlformats.org/drawingml/2006/main" xmlns:r="http://schemas.openxmlformats.org/officeDocument/2006/relationships" xmlns:p="http://schemas.openxmlformats.org/presentationml/2006/main">
+  <p:cSld>
+    <p:spTree>
+      <p:nvGrpSpPr>
+        <p:cNvPr id="1" name=""/>
+        <p:cNvGrpSpPr/>
+        <p:nvPr/>
+      </p:nvGrpSpPr>
+      <p:grpSpPr>
+        <a:xfrm>
+          <a:off x="0" y="0"/>
+          <a:ext cx="0" cy="0"/>
+          <a:chOff x="0" y="0"/>
+          <a:chExt cx="0" cy="0"/>
+        </a:xfrm>
+      </p:grpSpPr>
+      <p:sp>
+        <p:nvSpPr>
+          <p:cNvPr id="2" name="Slide Image Placeholder 1"/>
+          <p:cNvSpPr>
+            <a:spLocks noGrp="1" noRot="1" noChangeAspect="1"/>
+          </p:cNvSpPr>
+          <p:nvPr>
+            <p:ph type="sldImg"/>
+          </p:nvPr>
+        </p:nvSpPr>
+        <p:spPr/>
+      </p:sp>
+      <p:sp>
+        <p:nvSpPr>
+          <p:cNvPr id="3" name="Notes Placeholder 2"/>
+          <p:cNvSpPr>
+            <a:spLocks noGrp="1"/>
+          </p:cNvSpPr>
+          <p:nvPr>
+            <p:ph type="body" idx="1"/>
+          </p:nvPr>
+        </p:nvSpPr>
+        <p:spPr/>
+        <p:txBody>
+          <a:bodyPr/>
+          <a:lstStyle/>
+          <a:p>
+            <a:r>
+              <a:rPr lang="en-US" dirty="0"/>
+              <a:t>Before students leave, make sure everyone has joined your class and started the assignment. Collect any forgotten handles now; it saves time next class.</a:t>
+            </a:r>
+            <a:endParaRPr lang="en-US" dirty="0"/>
+          </a:p>
+        </p:txBody>
+      </p:sp>
+      <p:sp>
+        <p:nvSpPr>
+          <p:cNvPr id="4" name="Slide Number Placeholder 3"/>
+          <p:cNvSpPr>
+            <a:spLocks noGrp="1"/>
+          </p:cNvSpPr>
+          <p:nvPr>
+            <p:ph type="sldNum" sz="quarter" idx="10"/>
+          </p:nvPr>
+        </p:nvSpPr>
+        <p:spPr/>
+        <p:txBody>
+          <a:bodyPr/>
+          <a:lstStyle/>
+          <a:p>
+            <a:fld id="{F7021451-1387-4CA6-816F-3879F97B5CBC}" type="slidenum">
+              <a:rPr lang="en-US"/>
+              <a:t>16</a:t>
+            </a:fld>
+            <a:endParaRPr lang="en-US"/>
+          </a:p>
+        </p:txBody>
+      </p:sp>
+    </p:spTree>
+    <p:extLst>
+      <p:ext uri="{BB962C8B-B14F-4D97-AF65-F5344CB8AC3E}">
+        <p14:creationId xmlns:p14="http://schemas.microsoft.com/office/powerpoint/2010/main" val="1024086991"/>
+      </p:ext>
+    </p:extLst>
+  </p:cSld>
+  <p:clrMapOvr>
+    <a:masterClrMapping/>
+  </p:clrMapOvr>
+</p:notes>
+</file>
+
 <file path=ppt/notesSlides/notesSlide2.xml><?xml version="1.0" encoding="utf-8"?>
 <p:notes xmlns:a="http://schemas.openxmlformats.org/drawingml/2006/main" xmlns:r="http://schemas.openxmlformats.org/officeDocument/2006/relationships" xmlns:p="http://schemas.openxmlformats.org/presentationml/2006/main">
   <p:cSld>
@@ -1748,7 +1837,7 @@
           <a:p>
             <a:r>
               <a:rPr lang="en-US" dirty="0"/>
-              <a:t>Use "Bored in the USA" from the resources, or your own sample, as long as it follows our form (intro ending in a thesis, body paragraphs, conclusion). Everyone has a copy. Before reading, ask everyone to underline or highlight anything interesting, at least one thing per paragraph. Volunteers read aloud, a paragraph each. Don’t overanalyze.</a:t>
+              <a:t>Use "Bored in the USA" (the Sample essay handout, next to this deck in the Modules), or your own sample, as long as it follows our form (intro ending in a thesis, body paragraphs, conclusion). Everyone has a copy. Before reading, ask everyone to underline or highlight anything interesting, at least one thing per paragraph. Volunteers read aloud, a paragraph each. Don’t overanalyze.</a:t>
             </a:r>
             <a:endParaRPr lang="en-US" dirty="0"/>
           </a:p>
@@ -3192,12 +3281,12 @@
         </p:nvSpPr>
         <p:spPr>
           <a:xfrm>
-            <a:off x="685800" y="1965960"/>
-            <a:ext cx="3393338" cy="3749040"/>
+            <a:off x="685800" y="2652268"/>
+            <a:ext cx="3393338" cy="2742184"/>
           </a:xfrm>
           <a:prstGeom prst="roundRect">
             <a:avLst>
-              <a:gd name="adj" fmla="val 3773"/>
+              <a:gd name="adj" fmla="val 4668"/>
             </a:avLst>
           </a:prstGeom>
           <a:solidFill>
@@ -3226,7 +3315,7 @@
         </p:nvSpPr>
         <p:spPr>
           <a:xfrm>
-            <a:off x="813816" y="1965960"/>
+            <a:off x="813816" y="2652268"/>
             <a:ext cx="3137306" cy="91440"/>
           </a:xfrm>
           <a:prstGeom prst="rect">
@@ -3251,7 +3340,7 @@
         </p:nvSpPr>
         <p:spPr>
           <a:xfrm>
-            <a:off x="1005840" y="2331720"/>
+            <a:off x="1005840" y="3018028"/>
             <a:ext cx="731520" cy="731520"/>
           </a:xfrm>
           <a:prstGeom prst="ellipse">
@@ -3276,7 +3365,7 @@
         </p:nvSpPr>
         <p:spPr>
           <a:xfrm>
-            <a:off x="1005840" y="2331720"/>
+            <a:off x="1005840" y="3018028"/>
             <a:ext cx="731520" cy="731520"/>
           </a:xfrm>
           <a:prstGeom prst="rect">
@@ -3315,8 +3404,8 @@
         </p:nvSpPr>
         <p:spPr>
           <a:xfrm>
-            <a:off x="1005840" y="3246120"/>
-            <a:ext cx="2753258" cy="2286000"/>
+            <a:off x="1005840" y="3932428"/>
+            <a:ext cx="2753258" cy="1279144"/>
           </a:xfrm>
           <a:prstGeom prst="rect">
             <a:avLst/>
@@ -3332,7 +3421,7 @@
               <a:buNone/>
             </a:pPr>
             <a:r>
-              <a:rPr lang="en-US" sz="2600" dirty="0">
+              <a:rPr lang="en-US" sz="2800" dirty="0">
                 <a:solidFill>
                   <a:srgbClr val="3C3828"/>
                 </a:solidFill>
@@ -3342,7 +3431,7 @@
               </a:rPr>
               <a:t>What do you like about this essay?</a:t>
             </a:r>
-            <a:endParaRPr lang="en-US" sz="2600" dirty="0"/>
+            <a:endParaRPr lang="en-US" sz="2800" dirty="0"/>
           </a:p>
         </p:txBody>
       </p:sp>
@@ -3354,12 +3443,12 @@
         </p:nvSpPr>
         <p:spPr>
           <a:xfrm>
-            <a:off x="4399178" y="1965960"/>
-            <a:ext cx="3393338" cy="3749040"/>
+            <a:off x="4399178" y="2652268"/>
+            <a:ext cx="3393338" cy="2742184"/>
           </a:xfrm>
           <a:prstGeom prst="roundRect">
             <a:avLst>
-              <a:gd name="adj" fmla="val 3773"/>
+              <a:gd name="adj" fmla="val 4668"/>
             </a:avLst>
           </a:prstGeom>
           <a:solidFill>
@@ -3388,7 +3477,7 @@
         </p:nvSpPr>
         <p:spPr>
           <a:xfrm>
-            <a:off x="4527194" y="1965960"/>
+            <a:off x="4527194" y="2652268"/>
             <a:ext cx="3137306" cy="91440"/>
           </a:xfrm>
           <a:prstGeom prst="rect">
@@ -3413,7 +3502,7 @@
         </p:nvSpPr>
         <p:spPr>
           <a:xfrm>
-            <a:off x="4719218" y="2331720"/>
+            <a:off x="4719218" y="3018028"/>
             <a:ext cx="731520" cy="731520"/>
           </a:xfrm>
           <a:prstGeom prst="ellipse">
@@ -3438,7 +3527,7 @@
         </p:nvSpPr>
         <p:spPr>
           <a:xfrm>
-            <a:off x="4719218" y="2331720"/>
+            <a:off x="4719218" y="3018028"/>
             <a:ext cx="731520" cy="731520"/>
           </a:xfrm>
           <a:prstGeom prst="rect">
@@ -3477,8 +3566,8 @@
         </p:nvSpPr>
         <p:spPr>
           <a:xfrm>
-            <a:off x="4719218" y="3246120"/>
-            <a:ext cx="2753258" cy="2286000"/>
+            <a:off x="4719218" y="3932428"/>
+            <a:ext cx="2753258" cy="1279144"/>
           </a:xfrm>
           <a:prstGeom prst="rect">
             <a:avLst/>
@@ -3494,7 +3583,7 @@
               <a:buNone/>
             </a:pPr>
             <a:r>
-              <a:rPr lang="en-US" sz="2600" dirty="0">
+              <a:rPr lang="en-US" sz="2800" dirty="0">
                 <a:solidFill>
                   <a:srgbClr val="3C3828"/>
                 </a:solidFill>
@@ -3504,7 +3593,7 @@
               </a:rPr>
               <a:t>Do you agree with the writer?</a:t>
             </a:r>
-            <a:endParaRPr lang="en-US" sz="2600" dirty="0"/>
+            <a:endParaRPr lang="en-US" sz="2800" dirty="0"/>
           </a:p>
         </p:txBody>
       </p:sp>
@@ -3516,12 +3605,12 @@
         </p:nvSpPr>
         <p:spPr>
           <a:xfrm>
-            <a:off x="8112557" y="1965960"/>
-            <a:ext cx="3393338" cy="3749040"/>
+            <a:off x="8112557" y="2652268"/>
+            <a:ext cx="3393338" cy="2742184"/>
           </a:xfrm>
           <a:prstGeom prst="roundRect">
             <a:avLst>
-              <a:gd name="adj" fmla="val 3773"/>
+              <a:gd name="adj" fmla="val 4668"/>
             </a:avLst>
           </a:prstGeom>
           <a:solidFill>
@@ -3550,7 +3639,7 @@
         </p:nvSpPr>
         <p:spPr>
           <a:xfrm>
-            <a:off x="8240573" y="1965960"/>
+            <a:off x="8240573" y="2652268"/>
             <a:ext cx="3137306" cy="91440"/>
           </a:xfrm>
           <a:prstGeom prst="rect">
@@ -3575,7 +3664,7 @@
         </p:nvSpPr>
         <p:spPr>
           <a:xfrm>
-            <a:off x="8432597" y="2331720"/>
+            <a:off x="8432597" y="3018028"/>
             <a:ext cx="731520" cy="731520"/>
           </a:xfrm>
           <a:prstGeom prst="ellipse">
@@ -3600,7 +3689,7 @@
         </p:nvSpPr>
         <p:spPr>
           <a:xfrm>
-            <a:off x="8432597" y="2331720"/>
+            <a:off x="8432597" y="3018028"/>
             <a:ext cx="731520" cy="731520"/>
           </a:xfrm>
           <a:prstGeom prst="rect">
@@ -3639,8 +3728,8 @@
         </p:nvSpPr>
         <p:spPr>
           <a:xfrm>
-            <a:off x="8432597" y="3246120"/>
-            <a:ext cx="2753258" cy="2286000"/>
+            <a:off x="8432597" y="3932428"/>
+            <a:ext cx="2753258" cy="1279144"/>
           </a:xfrm>
           <a:prstGeom prst="rect">
             <a:avLst/>
@@ -3656,7 +3745,7 @@
               <a:buNone/>
             </a:pPr>
             <a:r>
-              <a:rPr lang="en-US" sz="2600" dirty="0">
+              <a:rPr lang="en-US" sz="2800" dirty="0">
                 <a:solidFill>
                   <a:srgbClr val="3C3828"/>
                 </a:solidFill>
@@ -3667,7 +3756,7 @@
               <a:t>What is the </a:t>
             </a:r>
             <a:r>
-              <a:rPr lang="en-US" sz="2600" dirty="0">
+              <a:rPr lang="en-US" sz="2800" dirty="0">
                 <a:solidFill>
                   <a:srgbClr val="3C3828"/>
                 </a:solidFill>
@@ -3680,7 +3769,7 @@
               </a:rPr>
               <a:t>main point or argument?</a:t>
             </a:r>
-            <a:endParaRPr lang="en-US" sz="2600" dirty="0"/>
+            <a:endParaRPr lang="en-US" sz="2800" dirty="0"/>
           </a:p>
         </p:txBody>
       </p:sp>
@@ -3765,7 +3854,7 @@
         </p:nvSpPr>
         <p:spPr>
           <a:xfrm>
-            <a:off x="685800" y="502920"/>
+            <a:off x="685800" y="274320"/>
             <a:ext cx="9357055" cy="320040"/>
           </a:xfrm>
           <a:prstGeom prst="rect">
@@ -3804,8 +3893,8 @@
         </p:nvSpPr>
         <p:spPr>
           <a:xfrm>
-            <a:off x="685800" y="868680"/>
-            <a:ext cx="9357055" cy="960120"/>
+            <a:off x="685800" y="621792"/>
+            <a:ext cx="9357055" cy="640080"/>
           </a:xfrm>
           <a:prstGeom prst="rect">
             <a:avLst/>
@@ -3821,7 +3910,7 @@
               <a:buNone/>
             </a:pPr>
             <a:r>
-              <a:rPr lang="en-US" sz="3600" dirty="0">
+              <a:rPr lang="en-US" sz="3200" dirty="0">
                 <a:solidFill>
                   <a:srgbClr val="3C3828"/>
                 </a:solidFill>
@@ -3829,9 +3918,9 @@
                 <a:ea typeface="Georgia" pitchFamily="34" charset="-122"/>
                 <a:cs typeface="Georgia" pitchFamily="34" charset="-120"/>
               </a:rPr>
-              <a:t>The Critical Essay Form</a:t>
-            </a:r>
-            <a:endParaRPr lang="en-US" sz="3600" dirty="0"/>
+              <a:t>The Critical Essay Form</a:t>
+            </a:r>
+            <a:endParaRPr lang="en-US" sz="3200" dirty="0"/>
           </a:p>
         </p:txBody>
       </p:sp>
@@ -3843,12 +3932,12 @@
         </p:nvSpPr>
         <p:spPr>
           <a:xfrm>
-            <a:off x="685800" y="1828800"/>
-            <a:ext cx="3355277" cy="4343400"/>
+            <a:off x="685800" y="1417320"/>
+            <a:ext cx="3708464" cy="4800600"/>
           </a:xfrm>
           <a:prstGeom prst="roundRect">
             <a:avLst>
-              <a:gd name="adj" fmla="val 3815"/>
+              <a:gd name="adj" fmla="val 3452"/>
             </a:avLst>
           </a:prstGeom>
           <a:solidFill>
@@ -3885,8 +3974,8 @@
         </p:blipFill>
         <p:spPr>
           <a:xfrm>
-            <a:off x="813816" y="1956816"/>
-            <a:ext cx="3099245" cy="4087368"/>
+            <a:off x="813816" y="1545336"/>
+            <a:ext cx="3452432" cy="4544568"/>
           </a:xfrm>
           <a:prstGeom prst="rect">
             <a:avLst/>
@@ -3901,8 +3990,8 @@
         </p:nvSpPr>
         <p:spPr>
           <a:xfrm>
-            <a:off x="4589717" y="2505456"/>
-            <a:ext cx="292608" cy="292608"/>
+            <a:off x="1517373" y="2316541"/>
+            <a:ext cx="457200" cy="457200"/>
           </a:xfrm>
           <a:prstGeom prst="ellipse">
             <a:avLst/>
@@ -3910,12 +3999,19 @@
           <a:solidFill>
             <a:srgbClr val="02BDC7"/>
           </a:solidFill>
-          <a:ln w="12700">
-            <a:solidFill>
-              <a:srgbClr val="02BDC7"/>
-            </a:solidFill>
-            <a:prstDash val="solid"/>
-          </a:ln>
+          <a:ln w="25400">
+            <a:solidFill>
+              <a:srgbClr val="FFFEFA"/>
+            </a:solidFill>
+            <a:prstDash val="solid"/>
+          </a:ln>
+          <a:effectLst>
+            <a:outerShdw sx="100000" sy="100000" kx="0" ky="0" algn="bl" rotWithShape="0" blurRad="50800" dist="19050" dir="5400000">
+              <a:srgbClr val="3C3828">
+                <a:alpha val="25000"/>
+              </a:srgbClr>
+            </a:outerShdw>
+          </a:effectLst>
         </p:spPr>
       </p:sp>
       <p:sp>
@@ -3926,8 +4022,331 @@
         </p:nvSpPr>
         <p:spPr>
           <a:xfrm>
-            <a:off x="5065205" y="2194560"/>
-            <a:ext cx="6440691" cy="914400"/>
+            <a:off x="1517373" y="2316541"/>
+            <a:ext cx="457200" cy="457200"/>
+          </a:xfrm>
+          <a:prstGeom prst="rect">
+            <a:avLst/>
+          </a:prstGeom>
+          <a:noFill/>
+          <a:ln/>
+        </p:spPr>
+        <p:txBody>
+          <a:bodyPr wrap="square" lIns="0" tIns="0" rIns="0" bIns="0" rtlCol="0" anchor="ctr"/>
+          <a:lstStyle/>
+          <a:p>
+            <a:pPr algn="ctr" indent="0" marL="0">
+              <a:buNone/>
+            </a:pPr>
+            <a:r>
+              <a:rPr lang="en-US" sz="1800" b="1" dirty="0">
+                <a:solidFill>
+                  <a:srgbClr val="FFFEFA"/>
+                </a:solidFill>
+                <a:latin typeface="Georgia" pitchFamily="34" charset="0"/>
+                <a:ea typeface="Georgia" pitchFamily="34" charset="-122"/>
+                <a:cs typeface="Georgia" pitchFamily="34" charset="-120"/>
+              </a:rPr>
+              <a:t>1</a:t>
+            </a:r>
+            <a:endParaRPr lang="en-US" sz="1800" dirty="0"/>
+          </a:p>
+        </p:txBody>
+      </p:sp>
+      <p:sp>
+        <p:nvSpPr>
+          <p:cNvPr id="8" name="Shape 5"/>
+          <p:cNvSpPr/>
+          <p:nvPr/>
+        </p:nvSpPr>
+        <p:spPr>
+          <a:xfrm>
+            <a:off x="2725724" y="2998226"/>
+            <a:ext cx="457200" cy="457200"/>
+          </a:xfrm>
+          <a:prstGeom prst="ellipse">
+            <a:avLst/>
+          </a:prstGeom>
+          <a:solidFill>
+            <a:srgbClr val="FFB600"/>
+          </a:solidFill>
+          <a:ln w="25400">
+            <a:solidFill>
+              <a:srgbClr val="FFFEFA"/>
+            </a:solidFill>
+            <a:prstDash val="solid"/>
+          </a:ln>
+          <a:effectLst>
+            <a:outerShdw sx="100000" sy="100000" kx="0" ky="0" algn="bl" rotWithShape="0" blurRad="50800" dist="19050" dir="5400000">
+              <a:srgbClr val="3C3828">
+                <a:alpha val="25000"/>
+              </a:srgbClr>
+            </a:outerShdw>
+          </a:effectLst>
+        </p:spPr>
+      </p:sp>
+      <p:sp>
+        <p:nvSpPr>
+          <p:cNvPr id="9" name="Text 6"/>
+          <p:cNvSpPr/>
+          <p:nvPr/>
+        </p:nvSpPr>
+        <p:spPr>
+          <a:xfrm>
+            <a:off x="2725724" y="2998226"/>
+            <a:ext cx="457200" cy="457200"/>
+          </a:xfrm>
+          <a:prstGeom prst="rect">
+            <a:avLst/>
+          </a:prstGeom>
+          <a:noFill/>
+          <a:ln/>
+        </p:spPr>
+        <p:txBody>
+          <a:bodyPr wrap="square" lIns="0" tIns="0" rIns="0" bIns="0" rtlCol="0" anchor="ctr"/>
+          <a:lstStyle/>
+          <a:p>
+            <a:pPr algn="ctr" indent="0" marL="0">
+              <a:buNone/>
+            </a:pPr>
+            <a:r>
+              <a:rPr lang="en-US" sz="1800" b="1" dirty="0">
+                <a:solidFill>
+                  <a:srgbClr val="FFFEFA"/>
+                </a:solidFill>
+                <a:latin typeface="Georgia" pitchFamily="34" charset="0"/>
+                <a:ea typeface="Georgia" pitchFamily="34" charset="-122"/>
+                <a:cs typeface="Georgia" pitchFamily="34" charset="-120"/>
+              </a:rPr>
+              <a:t>2</a:t>
+            </a:r>
+            <a:endParaRPr lang="en-US" sz="1800" dirty="0"/>
+          </a:p>
+        </p:txBody>
+      </p:sp>
+      <p:sp>
+        <p:nvSpPr>
+          <p:cNvPr id="10" name="Shape 7"/>
+          <p:cNvSpPr/>
+          <p:nvPr/>
+        </p:nvSpPr>
+        <p:spPr>
+          <a:xfrm>
+            <a:off x="2863821" y="3725357"/>
+            <a:ext cx="457200" cy="457200"/>
+          </a:xfrm>
+          <a:prstGeom prst="ellipse">
+            <a:avLst/>
+          </a:prstGeom>
+          <a:solidFill>
+            <a:srgbClr val="FC4540"/>
+          </a:solidFill>
+          <a:ln w="25400">
+            <a:solidFill>
+              <a:srgbClr val="FFFEFA"/>
+            </a:solidFill>
+            <a:prstDash val="solid"/>
+          </a:ln>
+          <a:effectLst>
+            <a:outerShdw sx="100000" sy="100000" kx="0" ky="0" algn="bl" rotWithShape="0" blurRad="50800" dist="19050" dir="5400000">
+              <a:srgbClr val="3C3828">
+                <a:alpha val="25000"/>
+              </a:srgbClr>
+            </a:outerShdw>
+          </a:effectLst>
+        </p:spPr>
+      </p:sp>
+      <p:sp>
+        <p:nvSpPr>
+          <p:cNvPr id="11" name="Text 8"/>
+          <p:cNvSpPr/>
+          <p:nvPr/>
+        </p:nvSpPr>
+        <p:spPr>
+          <a:xfrm>
+            <a:off x="2863821" y="3725357"/>
+            <a:ext cx="457200" cy="457200"/>
+          </a:xfrm>
+          <a:prstGeom prst="rect">
+            <a:avLst/>
+          </a:prstGeom>
+          <a:noFill/>
+          <a:ln/>
+        </p:spPr>
+        <p:txBody>
+          <a:bodyPr wrap="square" lIns="0" tIns="0" rIns="0" bIns="0" rtlCol="0" anchor="ctr"/>
+          <a:lstStyle/>
+          <a:p>
+            <a:pPr algn="ctr" indent="0" marL="0">
+              <a:buNone/>
+            </a:pPr>
+            <a:r>
+              <a:rPr lang="en-US" sz="1800" b="1" dirty="0">
+                <a:solidFill>
+                  <a:srgbClr val="FFFEFA"/>
+                </a:solidFill>
+                <a:latin typeface="Georgia" pitchFamily="34" charset="0"/>
+                <a:ea typeface="Georgia" pitchFamily="34" charset="-122"/>
+                <a:cs typeface="Georgia" pitchFamily="34" charset="-120"/>
+              </a:rPr>
+              <a:t>3</a:t>
+            </a:r>
+            <a:endParaRPr lang="en-US" sz="1800" dirty="0"/>
+          </a:p>
+        </p:txBody>
+      </p:sp>
+      <p:sp>
+        <p:nvSpPr>
+          <p:cNvPr id="12" name="Shape 9"/>
+          <p:cNvSpPr/>
+          <p:nvPr/>
+        </p:nvSpPr>
+        <p:spPr>
+          <a:xfrm>
+            <a:off x="3105491" y="5043282"/>
+            <a:ext cx="457200" cy="457200"/>
+          </a:xfrm>
+          <a:prstGeom prst="ellipse">
+            <a:avLst/>
+          </a:prstGeom>
+          <a:solidFill>
+            <a:srgbClr val="FF9755"/>
+          </a:solidFill>
+          <a:ln w="25400">
+            <a:solidFill>
+              <a:srgbClr val="FFFEFA"/>
+            </a:solidFill>
+            <a:prstDash val="solid"/>
+          </a:ln>
+          <a:effectLst>
+            <a:outerShdw sx="100000" sy="100000" kx="0" ky="0" algn="bl" rotWithShape="0" blurRad="50800" dist="19050" dir="5400000">
+              <a:srgbClr val="3C3828">
+                <a:alpha val="25000"/>
+              </a:srgbClr>
+            </a:outerShdw>
+          </a:effectLst>
+        </p:spPr>
+      </p:sp>
+      <p:sp>
+        <p:nvSpPr>
+          <p:cNvPr id="13" name="Text 10"/>
+          <p:cNvSpPr/>
+          <p:nvPr/>
+        </p:nvSpPr>
+        <p:spPr>
+          <a:xfrm>
+            <a:off x="3105491" y="5043282"/>
+            <a:ext cx="457200" cy="457200"/>
+          </a:xfrm>
+          <a:prstGeom prst="rect">
+            <a:avLst/>
+          </a:prstGeom>
+          <a:noFill/>
+          <a:ln/>
+        </p:spPr>
+        <p:txBody>
+          <a:bodyPr wrap="square" lIns="0" tIns="0" rIns="0" bIns="0" rtlCol="0" anchor="ctr"/>
+          <a:lstStyle/>
+          <a:p>
+            <a:pPr algn="ctr" indent="0" marL="0">
+              <a:buNone/>
+            </a:pPr>
+            <a:r>
+              <a:rPr lang="en-US" sz="1800" b="1" dirty="0">
+                <a:solidFill>
+                  <a:srgbClr val="FFFEFA"/>
+                </a:solidFill>
+                <a:latin typeface="Georgia" pitchFamily="34" charset="0"/>
+                <a:ea typeface="Georgia" pitchFamily="34" charset="-122"/>
+                <a:cs typeface="Georgia" pitchFamily="34" charset="-120"/>
+              </a:rPr>
+              <a:t>4</a:t>
+            </a:r>
+            <a:endParaRPr lang="en-US" sz="1800" dirty="0"/>
+          </a:p>
+        </p:txBody>
+      </p:sp>
+      <p:sp>
+        <p:nvSpPr>
+          <p:cNvPr id="14" name="Shape 11"/>
+          <p:cNvSpPr/>
+          <p:nvPr/>
+        </p:nvSpPr>
+        <p:spPr>
+          <a:xfrm>
+            <a:off x="4851464" y="2348484"/>
+            <a:ext cx="457200" cy="457200"/>
+          </a:xfrm>
+          <a:prstGeom prst="ellipse">
+            <a:avLst/>
+          </a:prstGeom>
+          <a:solidFill>
+            <a:srgbClr val="02BDC7"/>
+          </a:solidFill>
+          <a:ln w="25400">
+            <a:solidFill>
+              <a:srgbClr val="FFFEFA"/>
+            </a:solidFill>
+            <a:prstDash val="solid"/>
+          </a:ln>
+          <a:effectLst>
+            <a:outerShdw sx="100000" sy="100000" kx="0" ky="0" algn="bl" rotWithShape="0" blurRad="50800" dist="19050" dir="5400000">
+              <a:srgbClr val="3C3828">
+                <a:alpha val="25000"/>
+              </a:srgbClr>
+            </a:outerShdw>
+          </a:effectLst>
+        </p:spPr>
+      </p:sp>
+      <p:sp>
+        <p:nvSpPr>
+          <p:cNvPr id="15" name="Text 12"/>
+          <p:cNvSpPr/>
+          <p:nvPr/>
+        </p:nvSpPr>
+        <p:spPr>
+          <a:xfrm>
+            <a:off x="4851464" y="2348484"/>
+            <a:ext cx="457200" cy="457200"/>
+          </a:xfrm>
+          <a:prstGeom prst="rect">
+            <a:avLst/>
+          </a:prstGeom>
+          <a:noFill/>
+          <a:ln/>
+        </p:spPr>
+        <p:txBody>
+          <a:bodyPr wrap="square" lIns="0" tIns="0" rIns="0" bIns="0" rtlCol="0" anchor="ctr"/>
+          <a:lstStyle/>
+          <a:p>
+            <a:pPr algn="ctr" indent="0" marL="0">
+              <a:buNone/>
+            </a:pPr>
+            <a:r>
+              <a:rPr lang="en-US" sz="1800" b="1" dirty="0">
+                <a:solidFill>
+                  <a:srgbClr val="FFFEFA"/>
+                </a:solidFill>
+                <a:latin typeface="Georgia" pitchFamily="34" charset="0"/>
+                <a:ea typeface="Georgia" pitchFamily="34" charset="-122"/>
+                <a:cs typeface="Georgia" pitchFamily="34" charset="-120"/>
+              </a:rPr>
+              <a:t>1</a:t>
+            </a:r>
+            <a:endParaRPr lang="en-US" sz="1800" dirty="0"/>
+          </a:p>
+        </p:txBody>
+      </p:sp>
+      <p:sp>
+        <p:nvSpPr>
+          <p:cNvPr id="16" name="Text 13"/>
+          <p:cNvSpPr/>
+          <p:nvPr/>
+        </p:nvSpPr>
+        <p:spPr>
+          <a:xfrm>
+            <a:off x="5491544" y="2211324"/>
+            <a:ext cx="6014352" cy="731520"/>
           </a:xfrm>
           <a:prstGeom prst="rect">
             <a:avLst/>
@@ -3959,14 +4378,14 @@
       </p:sp>
       <p:sp>
         <p:nvSpPr>
-          <p:cNvPr id="8" name="Shape 5"/>
-          <p:cNvSpPr/>
-          <p:nvPr/>
-        </p:nvSpPr>
-        <p:spPr>
-          <a:xfrm>
-            <a:off x="4589717" y="3419856"/>
-            <a:ext cx="292608" cy="292608"/>
+          <p:cNvPr id="17" name="Shape 14"/>
+          <p:cNvSpPr/>
+          <p:nvPr/>
+        </p:nvSpPr>
+        <p:spPr>
+          <a:xfrm>
+            <a:off x="4851464" y="3223260"/>
+            <a:ext cx="457200" cy="457200"/>
           </a:xfrm>
           <a:prstGeom prst="ellipse">
             <a:avLst/>
@@ -3974,24 +4393,70 @@
           <a:solidFill>
             <a:srgbClr val="FFB600"/>
           </a:solidFill>
-          <a:ln w="12700">
-            <a:solidFill>
-              <a:srgbClr val="FFB600"/>
-            </a:solidFill>
-            <a:prstDash val="solid"/>
-          </a:ln>
-        </p:spPr>
-      </p:sp>
-      <p:sp>
-        <p:nvSpPr>
-          <p:cNvPr id="9" name="Text 6"/>
-          <p:cNvSpPr/>
-          <p:nvPr/>
-        </p:nvSpPr>
-        <p:spPr>
-          <a:xfrm>
-            <a:off x="5065205" y="3108960"/>
-            <a:ext cx="6440691" cy="914400"/>
+          <a:ln w="25400">
+            <a:solidFill>
+              <a:srgbClr val="FFFEFA"/>
+            </a:solidFill>
+            <a:prstDash val="solid"/>
+          </a:ln>
+          <a:effectLst>
+            <a:outerShdw sx="100000" sy="100000" kx="0" ky="0" algn="bl" rotWithShape="0" blurRad="50800" dist="19050" dir="5400000">
+              <a:srgbClr val="3C3828">
+                <a:alpha val="25000"/>
+              </a:srgbClr>
+            </a:outerShdw>
+          </a:effectLst>
+        </p:spPr>
+      </p:sp>
+      <p:sp>
+        <p:nvSpPr>
+          <p:cNvPr id="18" name="Text 15"/>
+          <p:cNvSpPr/>
+          <p:nvPr/>
+        </p:nvSpPr>
+        <p:spPr>
+          <a:xfrm>
+            <a:off x="4851464" y="3223260"/>
+            <a:ext cx="457200" cy="457200"/>
+          </a:xfrm>
+          <a:prstGeom prst="rect">
+            <a:avLst/>
+          </a:prstGeom>
+          <a:noFill/>
+          <a:ln/>
+        </p:spPr>
+        <p:txBody>
+          <a:bodyPr wrap="square" lIns="0" tIns="0" rIns="0" bIns="0" rtlCol="0" anchor="ctr"/>
+          <a:lstStyle/>
+          <a:p>
+            <a:pPr algn="ctr" indent="0" marL="0">
+              <a:buNone/>
+            </a:pPr>
+            <a:r>
+              <a:rPr lang="en-US" sz="1800" b="1" dirty="0">
+                <a:solidFill>
+                  <a:srgbClr val="FFFEFA"/>
+                </a:solidFill>
+                <a:latin typeface="Georgia" pitchFamily="34" charset="0"/>
+                <a:ea typeface="Georgia" pitchFamily="34" charset="-122"/>
+                <a:cs typeface="Georgia" pitchFamily="34" charset="-120"/>
+              </a:rPr>
+              <a:t>2</a:t>
+            </a:r>
+            <a:endParaRPr lang="en-US" sz="1800" dirty="0"/>
+          </a:p>
+        </p:txBody>
+      </p:sp>
+      <p:sp>
+        <p:nvSpPr>
+          <p:cNvPr id="19" name="Text 16"/>
+          <p:cNvSpPr/>
+          <p:nvPr/>
+        </p:nvSpPr>
+        <p:spPr>
+          <a:xfrm>
+            <a:off x="5491544" y="2942844"/>
+            <a:ext cx="6014352" cy="1018032"/>
           </a:xfrm>
           <a:prstGeom prst="rect">
             <a:avLst/>
@@ -4037,14 +4502,14 @@
       </p:sp>
       <p:sp>
         <p:nvSpPr>
-          <p:cNvPr id="10" name="Shape 7"/>
-          <p:cNvSpPr/>
-          <p:nvPr/>
-        </p:nvSpPr>
-        <p:spPr>
-          <a:xfrm>
-            <a:off x="4589717" y="4334256"/>
-            <a:ext cx="292608" cy="292608"/>
+          <p:cNvPr id="20" name="Shape 17"/>
+          <p:cNvSpPr/>
+          <p:nvPr/>
+        </p:nvSpPr>
+        <p:spPr>
+          <a:xfrm>
+            <a:off x="4851464" y="4098036"/>
+            <a:ext cx="457200" cy="457200"/>
           </a:xfrm>
           <a:prstGeom prst="ellipse">
             <a:avLst/>
@@ -4052,24 +4517,70 @@
           <a:solidFill>
             <a:srgbClr val="FC4540"/>
           </a:solidFill>
-          <a:ln w="12700">
-            <a:solidFill>
-              <a:srgbClr val="FC4540"/>
-            </a:solidFill>
-            <a:prstDash val="solid"/>
-          </a:ln>
-        </p:spPr>
-      </p:sp>
-      <p:sp>
-        <p:nvSpPr>
-          <p:cNvPr id="11" name="Text 8"/>
-          <p:cNvSpPr/>
-          <p:nvPr/>
-        </p:nvSpPr>
-        <p:spPr>
-          <a:xfrm>
-            <a:off x="5065205" y="4023360"/>
-            <a:ext cx="6440691" cy="914400"/>
+          <a:ln w="25400">
+            <a:solidFill>
+              <a:srgbClr val="FFFEFA"/>
+            </a:solidFill>
+            <a:prstDash val="solid"/>
+          </a:ln>
+          <a:effectLst>
+            <a:outerShdw sx="100000" sy="100000" kx="0" ky="0" algn="bl" rotWithShape="0" blurRad="50800" dist="19050" dir="5400000">
+              <a:srgbClr val="3C3828">
+                <a:alpha val="25000"/>
+              </a:srgbClr>
+            </a:outerShdw>
+          </a:effectLst>
+        </p:spPr>
+      </p:sp>
+      <p:sp>
+        <p:nvSpPr>
+          <p:cNvPr id="21" name="Text 18"/>
+          <p:cNvSpPr/>
+          <p:nvPr/>
+        </p:nvSpPr>
+        <p:spPr>
+          <a:xfrm>
+            <a:off x="4851464" y="4098036"/>
+            <a:ext cx="457200" cy="457200"/>
+          </a:xfrm>
+          <a:prstGeom prst="rect">
+            <a:avLst/>
+          </a:prstGeom>
+          <a:noFill/>
+          <a:ln/>
+        </p:spPr>
+        <p:txBody>
+          <a:bodyPr wrap="square" lIns="0" tIns="0" rIns="0" bIns="0" rtlCol="0" anchor="ctr"/>
+          <a:lstStyle/>
+          <a:p>
+            <a:pPr algn="ctr" indent="0" marL="0">
+              <a:buNone/>
+            </a:pPr>
+            <a:r>
+              <a:rPr lang="en-US" sz="1800" b="1" dirty="0">
+                <a:solidFill>
+                  <a:srgbClr val="FFFEFA"/>
+                </a:solidFill>
+                <a:latin typeface="Georgia" pitchFamily="34" charset="0"/>
+                <a:ea typeface="Georgia" pitchFamily="34" charset="-122"/>
+                <a:cs typeface="Georgia" pitchFamily="34" charset="-120"/>
+              </a:rPr>
+              <a:t>3</a:t>
+            </a:r>
+            <a:endParaRPr lang="en-US" sz="1800" dirty="0"/>
+          </a:p>
+        </p:txBody>
+      </p:sp>
+      <p:sp>
+        <p:nvSpPr>
+          <p:cNvPr id="22" name="Text 19"/>
+          <p:cNvSpPr/>
+          <p:nvPr/>
+        </p:nvSpPr>
+        <p:spPr>
+          <a:xfrm>
+            <a:off x="5491544" y="3960876"/>
+            <a:ext cx="6014352" cy="731520"/>
           </a:xfrm>
           <a:prstGeom prst="rect">
             <a:avLst/>
@@ -4101,14 +4612,14 @@
       </p:sp>
       <p:sp>
         <p:nvSpPr>
-          <p:cNvPr id="12" name="Shape 9"/>
-          <p:cNvSpPr/>
-          <p:nvPr/>
-        </p:nvSpPr>
-        <p:spPr>
-          <a:xfrm>
-            <a:off x="4589717" y="5248656"/>
-            <a:ext cx="292608" cy="292608"/>
+          <p:cNvPr id="23" name="Shape 20"/>
+          <p:cNvSpPr/>
+          <p:nvPr/>
+        </p:nvSpPr>
+        <p:spPr>
+          <a:xfrm>
+            <a:off x="4851464" y="4829556"/>
+            <a:ext cx="457200" cy="457200"/>
           </a:xfrm>
           <a:prstGeom prst="ellipse">
             <a:avLst/>
@@ -4116,24 +4627,70 @@
           <a:solidFill>
             <a:srgbClr val="FF9755"/>
           </a:solidFill>
-          <a:ln w="12700">
-            <a:solidFill>
-              <a:srgbClr val="FF9755"/>
-            </a:solidFill>
-            <a:prstDash val="solid"/>
-          </a:ln>
-        </p:spPr>
-      </p:sp>
-      <p:sp>
-        <p:nvSpPr>
-          <p:cNvPr id="13" name="Text 10"/>
-          <p:cNvSpPr/>
-          <p:nvPr/>
-        </p:nvSpPr>
-        <p:spPr>
-          <a:xfrm>
-            <a:off x="5065205" y="4937760"/>
-            <a:ext cx="6440691" cy="914400"/>
+          <a:ln w="25400">
+            <a:solidFill>
+              <a:srgbClr val="FFFEFA"/>
+            </a:solidFill>
+            <a:prstDash val="solid"/>
+          </a:ln>
+          <a:effectLst>
+            <a:outerShdw sx="100000" sy="100000" kx="0" ky="0" algn="bl" rotWithShape="0" blurRad="50800" dist="19050" dir="5400000">
+              <a:srgbClr val="3C3828">
+                <a:alpha val="25000"/>
+              </a:srgbClr>
+            </a:outerShdw>
+          </a:effectLst>
+        </p:spPr>
+      </p:sp>
+      <p:sp>
+        <p:nvSpPr>
+          <p:cNvPr id="24" name="Text 21"/>
+          <p:cNvSpPr/>
+          <p:nvPr/>
+        </p:nvSpPr>
+        <p:spPr>
+          <a:xfrm>
+            <a:off x="4851464" y="4829556"/>
+            <a:ext cx="457200" cy="457200"/>
+          </a:xfrm>
+          <a:prstGeom prst="rect">
+            <a:avLst/>
+          </a:prstGeom>
+          <a:noFill/>
+          <a:ln/>
+        </p:spPr>
+        <p:txBody>
+          <a:bodyPr wrap="square" lIns="0" tIns="0" rIns="0" bIns="0" rtlCol="0" anchor="ctr"/>
+          <a:lstStyle/>
+          <a:p>
+            <a:pPr algn="ctr" indent="0" marL="0">
+              <a:buNone/>
+            </a:pPr>
+            <a:r>
+              <a:rPr lang="en-US" sz="1800" b="1" dirty="0">
+                <a:solidFill>
+                  <a:srgbClr val="FFFEFA"/>
+                </a:solidFill>
+                <a:latin typeface="Georgia" pitchFamily="34" charset="0"/>
+                <a:ea typeface="Georgia" pitchFamily="34" charset="-122"/>
+                <a:cs typeface="Georgia" pitchFamily="34" charset="-120"/>
+              </a:rPr>
+              <a:t>4</a:t>
+            </a:r>
+            <a:endParaRPr lang="en-US" sz="1800" dirty="0"/>
+          </a:p>
+        </p:txBody>
+      </p:sp>
+      <p:sp>
+        <p:nvSpPr>
+          <p:cNvPr id="25" name="Text 22"/>
+          <p:cNvSpPr/>
+          <p:nvPr/>
+        </p:nvSpPr>
+        <p:spPr>
+          <a:xfrm>
+            <a:off x="5491544" y="4692396"/>
+            <a:ext cx="6014352" cy="731520"/>
           </a:xfrm>
           <a:prstGeom prst="rect">
             <a:avLst/>
@@ -4308,7 +4865,7 @@
                 <a:ea typeface="Georgia" pitchFamily="34" charset="-122"/>
                 <a:cs typeface="Georgia" pitchFamily="34" charset="-120"/>
               </a:rPr>
-              <a:t>What are we doing here?</a:t>
+              <a:t>What are we doing here?</a:t>
             </a:r>
             <a:endParaRPr lang="en-US" sz="3600" dirty="0"/>
           </a:p>
@@ -4485,12 +5042,12 @@
         </p:nvSpPr>
         <p:spPr>
           <a:xfrm>
-            <a:off x="685800" y="2971800"/>
-            <a:ext cx="3393338" cy="3108960"/>
+            <a:off x="685800" y="2984754"/>
+            <a:ext cx="3393338" cy="3083052"/>
           </a:xfrm>
           <a:prstGeom prst="roundRect">
             <a:avLst>
-              <a:gd name="adj" fmla="val 4118"/>
+              <a:gd name="adj" fmla="val 4152"/>
             </a:avLst>
           </a:prstGeom>
           <a:solidFill>
@@ -4519,7 +5076,7 @@
         </p:nvSpPr>
         <p:spPr>
           <a:xfrm>
-            <a:off x="813816" y="2971800"/>
+            <a:off x="813816" y="2984754"/>
             <a:ext cx="3137306" cy="91440"/>
           </a:xfrm>
           <a:prstGeom prst="rect">
@@ -4544,7 +5101,7 @@
         </p:nvSpPr>
         <p:spPr>
           <a:xfrm>
-            <a:off x="1005840" y="3337560"/>
+            <a:off x="1005840" y="3350514"/>
             <a:ext cx="731520" cy="731520"/>
           </a:xfrm>
           <a:prstGeom prst="ellipse">
@@ -4569,7 +5126,7 @@
         </p:nvSpPr>
         <p:spPr>
           <a:xfrm>
-            <a:off x="1005840" y="3337560"/>
+            <a:off x="1005840" y="3350514"/>
             <a:ext cx="731520" cy="731520"/>
           </a:xfrm>
           <a:prstGeom prst="rect">
@@ -4608,8 +5165,8 @@
         </p:nvSpPr>
         <p:spPr>
           <a:xfrm>
-            <a:off x="1005840" y="4251960"/>
-            <a:ext cx="2753258" cy="1645920"/>
+            <a:off x="1005840" y="4264914"/>
+            <a:ext cx="2753258" cy="1620012"/>
           </a:xfrm>
           <a:prstGeom prst="rect">
             <a:avLst/>
@@ -4647,12 +5204,12 @@
         </p:nvSpPr>
         <p:spPr>
           <a:xfrm>
-            <a:off x="4399178" y="2971800"/>
-            <a:ext cx="3393338" cy="3108960"/>
+            <a:off x="4399178" y="2984754"/>
+            <a:ext cx="3393338" cy="3083052"/>
           </a:xfrm>
           <a:prstGeom prst="roundRect">
             <a:avLst>
-              <a:gd name="adj" fmla="val 4118"/>
+              <a:gd name="adj" fmla="val 4152"/>
             </a:avLst>
           </a:prstGeom>
           <a:solidFill>
@@ -4681,7 +5238,7 @@
         </p:nvSpPr>
         <p:spPr>
           <a:xfrm>
-            <a:off x="4527194" y="2971800"/>
+            <a:off x="4527194" y="2984754"/>
             <a:ext cx="3137306" cy="91440"/>
           </a:xfrm>
           <a:prstGeom prst="rect">
@@ -4706,7 +5263,7 @@
         </p:nvSpPr>
         <p:spPr>
           <a:xfrm>
-            <a:off x="4719218" y="3337560"/>
+            <a:off x="4719218" y="3350514"/>
             <a:ext cx="731520" cy="731520"/>
           </a:xfrm>
           <a:prstGeom prst="ellipse">
@@ -4731,7 +5288,7 @@
         </p:nvSpPr>
         <p:spPr>
           <a:xfrm>
-            <a:off x="4719218" y="3337560"/>
+            <a:off x="4719218" y="3350514"/>
             <a:ext cx="731520" cy="731520"/>
           </a:xfrm>
           <a:prstGeom prst="rect">
@@ -4770,8 +5327,8 @@
         </p:nvSpPr>
         <p:spPr>
           <a:xfrm>
-            <a:off x="4719218" y="4251960"/>
-            <a:ext cx="2753258" cy="1645920"/>
+            <a:off x="4719218" y="4264914"/>
+            <a:ext cx="2753258" cy="1620012"/>
           </a:xfrm>
           <a:prstGeom prst="rect">
             <a:avLst/>
@@ -4809,12 +5366,12 @@
         </p:nvSpPr>
         <p:spPr>
           <a:xfrm>
-            <a:off x="8112557" y="2971800"/>
-            <a:ext cx="3393338" cy="3108960"/>
+            <a:off x="8112557" y="2984754"/>
+            <a:ext cx="3393338" cy="3083052"/>
           </a:xfrm>
           <a:prstGeom prst="roundRect">
             <a:avLst>
-              <a:gd name="adj" fmla="val 4118"/>
+              <a:gd name="adj" fmla="val 4152"/>
             </a:avLst>
           </a:prstGeom>
           <a:solidFill>
@@ -4843,7 +5400,7 @@
         </p:nvSpPr>
         <p:spPr>
           <a:xfrm>
-            <a:off x="8240573" y="2971800"/>
+            <a:off x="8240573" y="2984754"/>
             <a:ext cx="3137306" cy="91440"/>
           </a:xfrm>
           <a:prstGeom prst="rect">
@@ -4868,7 +5425,7 @@
         </p:nvSpPr>
         <p:spPr>
           <a:xfrm>
-            <a:off x="8432597" y="3337560"/>
+            <a:off x="8432597" y="3350514"/>
             <a:ext cx="731520" cy="731520"/>
           </a:xfrm>
           <a:prstGeom prst="ellipse">
@@ -4893,7 +5450,7 @@
         </p:nvSpPr>
         <p:spPr>
           <a:xfrm>
-            <a:off x="8432597" y="3337560"/>
+            <a:off x="8432597" y="3350514"/>
             <a:ext cx="731520" cy="731520"/>
           </a:xfrm>
           <a:prstGeom prst="rect">
@@ -4932,8 +5489,8 @@
         </p:nvSpPr>
         <p:spPr>
           <a:xfrm>
-            <a:off x="8432597" y="4251960"/>
-            <a:ext cx="2753258" cy="1645920"/>
+            <a:off x="8432597" y="4264914"/>
+            <a:ext cx="2753258" cy="1620012"/>
           </a:xfrm>
           <a:prstGeom prst="rect">
             <a:avLst/>
@@ -5108,7 +5665,7 @@
                 <a:ea typeface="Georgia" pitchFamily="34" charset="-122"/>
                 <a:cs typeface="Georgia" pitchFamily="34" charset="-120"/>
               </a:rPr>
-              <a:t>Share your class’s join link</a:t>
+              <a:t>Share your class’s join link</a:t>
             </a:r>
             <a:endParaRPr lang="en-US" sz="3600" dirty="0"/>
           </a:p>
@@ -5286,7 +5843,7 @@
         <p:spPr>
           <a:xfrm>
             <a:off x="1417320" y="1965960"/>
-            <a:ext cx="4449928" cy="822960"/>
+            <a:ext cx="4449928" cy="685800"/>
           </a:xfrm>
           <a:prstGeom prst="rect">
             <a:avLst/>
@@ -5414,7 +5971,7 @@
         <p:spPr>
           <a:xfrm>
             <a:off x="7055968" y="1965960"/>
-            <a:ext cx="4449928" cy="822960"/>
+            <a:ext cx="4449928" cy="685800"/>
           </a:xfrm>
           <a:prstGeom prst="rect">
             <a:avLst/>
@@ -5477,7 +6034,7 @@
         </p:nvSpPr>
         <p:spPr>
           <a:xfrm>
-            <a:off x="685800" y="2944368"/>
+            <a:off x="685800" y="2807208"/>
             <a:ext cx="548640" cy="548640"/>
           </a:xfrm>
           <a:prstGeom prst="ellipse">
@@ -5502,7 +6059,7 @@
         </p:nvSpPr>
         <p:spPr>
           <a:xfrm>
-            <a:off x="685800" y="2944368"/>
+            <a:off x="685800" y="2807208"/>
             <a:ext cx="548640" cy="548640"/>
           </a:xfrm>
           <a:prstGeom prst="rect">
@@ -5541,8 +6098,8 @@
         </p:nvSpPr>
         <p:spPr>
           <a:xfrm>
-            <a:off x="1417320" y="2834640"/>
-            <a:ext cx="4449928" cy="822960"/>
+            <a:off x="1417320" y="2697480"/>
+            <a:ext cx="4449928" cy="685800"/>
           </a:xfrm>
           <a:prstGeom prst="rect">
             <a:avLst/>
@@ -5580,7 +6137,7 @@
         </p:nvSpPr>
         <p:spPr>
           <a:xfrm>
-            <a:off x="6324448" y="2944368"/>
+            <a:off x="6324448" y="2807208"/>
             <a:ext cx="548640" cy="548640"/>
           </a:xfrm>
           <a:prstGeom prst="ellipse">
@@ -5605,7 +6162,7 @@
         </p:nvSpPr>
         <p:spPr>
           <a:xfrm>
-            <a:off x="6324448" y="2944368"/>
+            <a:off x="6324448" y="2807208"/>
             <a:ext cx="548640" cy="548640"/>
           </a:xfrm>
           <a:prstGeom prst="rect">
@@ -5644,8 +6201,8 @@
         </p:nvSpPr>
         <p:spPr>
           <a:xfrm>
-            <a:off x="7055968" y="2834640"/>
-            <a:ext cx="4449928" cy="822960"/>
+            <a:off x="7055968" y="2697480"/>
+            <a:ext cx="4449928" cy="685800"/>
           </a:xfrm>
           <a:prstGeom prst="rect">
             <a:avLst/>
@@ -5708,12 +6265,12 @@
         </p:nvSpPr>
         <p:spPr>
           <a:xfrm>
-            <a:off x="2063915" y="3931920"/>
-            <a:ext cx="8063865" cy="2148840"/>
+            <a:off x="1120940" y="3611880"/>
+            <a:ext cx="9949815" cy="2606040"/>
           </a:xfrm>
           <a:prstGeom prst="roundRect">
             <a:avLst>
-              <a:gd name="adj" fmla="val 5957"/>
+              <a:gd name="adj" fmla="val 4912"/>
             </a:avLst>
           </a:prstGeom>
           <a:solidFill>
@@ -5750,8 +6307,8 @@
         </p:blipFill>
         <p:spPr>
           <a:xfrm>
-            <a:off x="2191931" y="4059936"/>
-            <a:ext cx="7807833" cy="1892808"/>
+            <a:off x="1248956" y="3739896"/>
+            <a:ext cx="9693783" cy="2350008"/>
           </a:xfrm>
           <a:prstGeom prst="rect">
             <a:avLst/>
@@ -5839,7 +6396,7 @@
         </p:nvSpPr>
         <p:spPr>
           <a:xfrm>
-            <a:off x="685800" y="502920"/>
+            <a:off x="685800" y="274320"/>
             <a:ext cx="9357055" cy="320040"/>
           </a:xfrm>
           <a:prstGeom prst="rect">
@@ -5878,8 +6435,8 @@
         </p:nvSpPr>
         <p:spPr>
           <a:xfrm>
-            <a:off x="685800" y="868680"/>
-            <a:ext cx="9357055" cy="960120"/>
+            <a:off x="685800" y="621792"/>
+            <a:ext cx="9357055" cy="640080"/>
           </a:xfrm>
           <a:prstGeom prst="rect">
             <a:avLst/>
@@ -5895,7 +6452,7 @@
               <a:buNone/>
             </a:pPr>
             <a:r>
-              <a:rPr lang="en-US" sz="3600" dirty="0">
+              <a:rPr lang="en-US" sz="3200" dirty="0">
                 <a:solidFill>
                   <a:srgbClr val="3C3828"/>
                 </a:solidFill>
@@ -5903,9 +6460,9 @@
                 <a:ea typeface="Georgia" pitchFamily="34" charset="-122"/>
                 <a:cs typeface="Georgia" pitchFamily="34" charset="-120"/>
               </a:rPr>
-              <a:t>Create your student account</a:t>
-            </a:r>
-            <a:endParaRPr lang="en-US" sz="3600" dirty="0"/>
+              <a:t>Create your student account</a:t>
+            </a:r>
+            <a:endParaRPr lang="en-US" sz="3200" dirty="0"/>
           </a:p>
         </p:txBody>
       </p:sp>
@@ -5917,12 +6474,12 @@
         </p:nvSpPr>
         <p:spPr>
           <a:xfrm>
-            <a:off x="685800" y="1828800"/>
-            <a:ext cx="1786999" cy="4343400"/>
+            <a:off x="685800" y="1417320"/>
+            <a:ext cx="1975104" cy="4800600"/>
           </a:xfrm>
           <a:prstGeom prst="roundRect">
             <a:avLst>
-              <a:gd name="adj" fmla="val 7164"/>
+              <a:gd name="adj" fmla="val 6481"/>
             </a:avLst>
           </a:prstGeom>
           <a:solidFill>
@@ -5959,8 +6516,8 @@
         </p:blipFill>
         <p:spPr>
           <a:xfrm>
-            <a:off x="813816" y="1956816"/>
-            <a:ext cx="1530967" cy="4087368"/>
+            <a:off x="813816" y="1545336"/>
+            <a:ext cx="1719072" cy="4544568"/>
           </a:xfrm>
           <a:prstGeom prst="rect">
             <a:avLst/>
@@ -5975,8 +6532,8 @@
         </p:nvSpPr>
         <p:spPr>
           <a:xfrm>
-            <a:off x="3021439" y="2505456"/>
-            <a:ext cx="292608" cy="292608"/>
+            <a:off x="2132381" y="2839166"/>
+            <a:ext cx="457200" cy="457200"/>
           </a:xfrm>
           <a:prstGeom prst="ellipse">
             <a:avLst/>
@@ -5984,12 +6541,19 @@
           <a:solidFill>
             <a:srgbClr val="FFB600"/>
           </a:solidFill>
-          <a:ln w="12700">
-            <a:solidFill>
-              <a:srgbClr val="FFB600"/>
-            </a:solidFill>
-            <a:prstDash val="solid"/>
-          </a:ln>
+          <a:ln w="25400">
+            <a:solidFill>
+              <a:srgbClr val="FFFEFA"/>
+            </a:solidFill>
+            <a:prstDash val="solid"/>
+          </a:ln>
+          <a:effectLst>
+            <a:outerShdw sx="100000" sy="100000" kx="0" ky="0" algn="bl" rotWithShape="0" blurRad="50800" dist="19050" dir="5400000">
+              <a:srgbClr val="3C3828">
+                <a:alpha val="25000"/>
+              </a:srgbClr>
+            </a:outerShdw>
+          </a:effectLst>
         </p:spPr>
       </p:sp>
       <p:sp>
@@ -6000,8 +6564,331 @@
         </p:nvSpPr>
         <p:spPr>
           <a:xfrm>
-            <a:off x="3496927" y="2194560"/>
-            <a:ext cx="8008968" cy="914400"/>
+            <a:off x="2132381" y="2839166"/>
+            <a:ext cx="457200" cy="457200"/>
+          </a:xfrm>
+          <a:prstGeom prst="rect">
+            <a:avLst/>
+          </a:prstGeom>
+          <a:noFill/>
+          <a:ln/>
+        </p:spPr>
+        <p:txBody>
+          <a:bodyPr wrap="square" lIns="0" tIns="0" rIns="0" bIns="0" rtlCol="0" anchor="ctr"/>
+          <a:lstStyle/>
+          <a:p>
+            <a:pPr algn="ctr" indent="0" marL="0">
+              <a:buNone/>
+            </a:pPr>
+            <a:r>
+              <a:rPr lang="en-US" sz="1800" b="1" dirty="0">
+                <a:solidFill>
+                  <a:srgbClr val="FFFEFA"/>
+                </a:solidFill>
+                <a:latin typeface="Georgia" pitchFamily="34" charset="0"/>
+                <a:ea typeface="Georgia" pitchFamily="34" charset="-122"/>
+                <a:cs typeface="Georgia" pitchFamily="34" charset="-120"/>
+              </a:rPr>
+              <a:t>1</a:t>
+            </a:r>
+            <a:endParaRPr lang="en-US" sz="1800" dirty="0"/>
+          </a:p>
+        </p:txBody>
+      </p:sp>
+      <p:sp>
+        <p:nvSpPr>
+          <p:cNvPr id="8" name="Shape 5"/>
+          <p:cNvSpPr/>
+          <p:nvPr/>
+        </p:nvSpPr>
+        <p:spPr>
+          <a:xfrm>
+            <a:off x="2080809" y="3748080"/>
+            <a:ext cx="457200" cy="457200"/>
+          </a:xfrm>
+          <a:prstGeom prst="ellipse">
+            <a:avLst/>
+          </a:prstGeom>
+          <a:solidFill>
+            <a:srgbClr val="FC4540"/>
+          </a:solidFill>
+          <a:ln w="25400">
+            <a:solidFill>
+              <a:srgbClr val="FFFEFA"/>
+            </a:solidFill>
+            <a:prstDash val="solid"/>
+          </a:ln>
+          <a:effectLst>
+            <a:outerShdw sx="100000" sy="100000" kx="0" ky="0" algn="bl" rotWithShape="0" blurRad="50800" dist="19050" dir="5400000">
+              <a:srgbClr val="3C3828">
+                <a:alpha val="25000"/>
+              </a:srgbClr>
+            </a:outerShdw>
+          </a:effectLst>
+        </p:spPr>
+      </p:sp>
+      <p:sp>
+        <p:nvSpPr>
+          <p:cNvPr id="9" name="Text 6"/>
+          <p:cNvSpPr/>
+          <p:nvPr/>
+        </p:nvSpPr>
+        <p:spPr>
+          <a:xfrm>
+            <a:off x="2080809" y="3748080"/>
+            <a:ext cx="457200" cy="457200"/>
+          </a:xfrm>
+          <a:prstGeom prst="rect">
+            <a:avLst/>
+          </a:prstGeom>
+          <a:noFill/>
+          <a:ln/>
+        </p:spPr>
+        <p:txBody>
+          <a:bodyPr wrap="square" lIns="0" tIns="0" rIns="0" bIns="0" rtlCol="0" anchor="ctr"/>
+          <a:lstStyle/>
+          <a:p>
+            <a:pPr algn="ctr" indent="0" marL="0">
+              <a:buNone/>
+            </a:pPr>
+            <a:r>
+              <a:rPr lang="en-US" sz="1800" b="1" dirty="0">
+                <a:solidFill>
+                  <a:srgbClr val="FFFEFA"/>
+                </a:solidFill>
+                <a:latin typeface="Georgia" pitchFamily="34" charset="0"/>
+                <a:ea typeface="Georgia" pitchFamily="34" charset="-122"/>
+                <a:cs typeface="Georgia" pitchFamily="34" charset="-120"/>
+              </a:rPr>
+              <a:t>2</a:t>
+            </a:r>
+            <a:endParaRPr lang="en-US" sz="1800" dirty="0"/>
+          </a:p>
+        </p:txBody>
+      </p:sp>
+      <p:sp>
+        <p:nvSpPr>
+          <p:cNvPr id="10" name="Shape 7"/>
+          <p:cNvSpPr/>
+          <p:nvPr/>
+        </p:nvSpPr>
+        <p:spPr>
+          <a:xfrm>
+            <a:off x="2080809" y="4179814"/>
+            <a:ext cx="457200" cy="457200"/>
+          </a:xfrm>
+          <a:prstGeom prst="ellipse">
+            <a:avLst/>
+          </a:prstGeom>
+          <a:solidFill>
+            <a:srgbClr val="FF9755"/>
+          </a:solidFill>
+          <a:ln w="25400">
+            <a:solidFill>
+              <a:srgbClr val="FFFEFA"/>
+            </a:solidFill>
+            <a:prstDash val="solid"/>
+          </a:ln>
+          <a:effectLst>
+            <a:outerShdw sx="100000" sy="100000" kx="0" ky="0" algn="bl" rotWithShape="0" blurRad="50800" dist="19050" dir="5400000">
+              <a:srgbClr val="3C3828">
+                <a:alpha val="25000"/>
+              </a:srgbClr>
+            </a:outerShdw>
+          </a:effectLst>
+        </p:spPr>
+      </p:sp>
+      <p:sp>
+        <p:nvSpPr>
+          <p:cNvPr id="11" name="Text 8"/>
+          <p:cNvSpPr/>
+          <p:nvPr/>
+        </p:nvSpPr>
+        <p:spPr>
+          <a:xfrm>
+            <a:off x="2080809" y="4179814"/>
+            <a:ext cx="457200" cy="457200"/>
+          </a:xfrm>
+          <a:prstGeom prst="rect">
+            <a:avLst/>
+          </a:prstGeom>
+          <a:noFill/>
+          <a:ln/>
+        </p:spPr>
+        <p:txBody>
+          <a:bodyPr wrap="square" lIns="0" tIns="0" rIns="0" bIns="0" rtlCol="0" anchor="ctr"/>
+          <a:lstStyle/>
+          <a:p>
+            <a:pPr algn="ctr" indent="0" marL="0">
+              <a:buNone/>
+            </a:pPr>
+            <a:r>
+              <a:rPr lang="en-US" sz="1800" b="1" dirty="0">
+                <a:solidFill>
+                  <a:srgbClr val="FFFEFA"/>
+                </a:solidFill>
+                <a:latin typeface="Georgia" pitchFamily="34" charset="0"/>
+                <a:ea typeface="Georgia" pitchFamily="34" charset="-122"/>
+                <a:cs typeface="Georgia" pitchFamily="34" charset="-120"/>
+              </a:rPr>
+              <a:t>3</a:t>
+            </a:r>
+            <a:endParaRPr lang="en-US" sz="1800" dirty="0"/>
+          </a:p>
+        </p:txBody>
+      </p:sp>
+      <p:sp>
+        <p:nvSpPr>
+          <p:cNvPr id="12" name="Shape 9"/>
+          <p:cNvSpPr/>
+          <p:nvPr/>
+        </p:nvSpPr>
+        <p:spPr>
+          <a:xfrm>
+            <a:off x="2080809" y="5588630"/>
+            <a:ext cx="457200" cy="457200"/>
+          </a:xfrm>
+          <a:prstGeom prst="ellipse">
+            <a:avLst/>
+          </a:prstGeom>
+          <a:solidFill>
+            <a:srgbClr val="FC4067"/>
+          </a:solidFill>
+          <a:ln w="25400">
+            <a:solidFill>
+              <a:srgbClr val="FFFEFA"/>
+            </a:solidFill>
+            <a:prstDash val="solid"/>
+          </a:ln>
+          <a:effectLst>
+            <a:outerShdw sx="100000" sy="100000" kx="0" ky="0" algn="bl" rotWithShape="0" blurRad="50800" dist="19050" dir="5400000">
+              <a:srgbClr val="3C3828">
+                <a:alpha val="25000"/>
+              </a:srgbClr>
+            </a:outerShdw>
+          </a:effectLst>
+        </p:spPr>
+      </p:sp>
+      <p:sp>
+        <p:nvSpPr>
+          <p:cNvPr id="13" name="Text 10"/>
+          <p:cNvSpPr/>
+          <p:nvPr/>
+        </p:nvSpPr>
+        <p:spPr>
+          <a:xfrm>
+            <a:off x="2080809" y="5588630"/>
+            <a:ext cx="457200" cy="457200"/>
+          </a:xfrm>
+          <a:prstGeom prst="rect">
+            <a:avLst/>
+          </a:prstGeom>
+          <a:noFill/>
+          <a:ln/>
+        </p:spPr>
+        <p:txBody>
+          <a:bodyPr wrap="square" lIns="0" tIns="0" rIns="0" bIns="0" rtlCol="0" anchor="ctr"/>
+          <a:lstStyle/>
+          <a:p>
+            <a:pPr algn="ctr" indent="0" marL="0">
+              <a:buNone/>
+            </a:pPr>
+            <a:r>
+              <a:rPr lang="en-US" sz="1800" b="1" dirty="0">
+                <a:solidFill>
+                  <a:srgbClr val="FFFEFA"/>
+                </a:solidFill>
+                <a:latin typeface="Georgia" pitchFamily="34" charset="0"/>
+                <a:ea typeface="Georgia" pitchFamily="34" charset="-122"/>
+                <a:cs typeface="Georgia" pitchFamily="34" charset="-120"/>
+              </a:rPr>
+              <a:t>4</a:t>
+            </a:r>
+            <a:endParaRPr lang="en-US" sz="1800" dirty="0"/>
+          </a:p>
+        </p:txBody>
+      </p:sp>
+      <p:sp>
+        <p:nvSpPr>
+          <p:cNvPr id="14" name="Shape 11"/>
+          <p:cNvSpPr/>
+          <p:nvPr/>
+        </p:nvSpPr>
+        <p:spPr>
+          <a:xfrm>
+            <a:off x="3118104" y="2491740"/>
+            <a:ext cx="457200" cy="457200"/>
+          </a:xfrm>
+          <a:prstGeom prst="ellipse">
+            <a:avLst/>
+          </a:prstGeom>
+          <a:solidFill>
+            <a:srgbClr val="FFB600"/>
+          </a:solidFill>
+          <a:ln w="25400">
+            <a:solidFill>
+              <a:srgbClr val="FFFEFA"/>
+            </a:solidFill>
+            <a:prstDash val="solid"/>
+          </a:ln>
+          <a:effectLst>
+            <a:outerShdw sx="100000" sy="100000" kx="0" ky="0" algn="bl" rotWithShape="0" blurRad="50800" dist="19050" dir="5400000">
+              <a:srgbClr val="3C3828">
+                <a:alpha val="25000"/>
+              </a:srgbClr>
+            </a:outerShdw>
+          </a:effectLst>
+        </p:spPr>
+      </p:sp>
+      <p:sp>
+        <p:nvSpPr>
+          <p:cNvPr id="15" name="Text 12"/>
+          <p:cNvSpPr/>
+          <p:nvPr/>
+        </p:nvSpPr>
+        <p:spPr>
+          <a:xfrm>
+            <a:off x="3118104" y="2491740"/>
+            <a:ext cx="457200" cy="457200"/>
+          </a:xfrm>
+          <a:prstGeom prst="rect">
+            <a:avLst/>
+          </a:prstGeom>
+          <a:noFill/>
+          <a:ln/>
+        </p:spPr>
+        <p:txBody>
+          <a:bodyPr wrap="square" lIns="0" tIns="0" rIns="0" bIns="0" rtlCol="0" anchor="ctr"/>
+          <a:lstStyle/>
+          <a:p>
+            <a:pPr algn="ctr" indent="0" marL="0">
+              <a:buNone/>
+            </a:pPr>
+            <a:r>
+              <a:rPr lang="en-US" sz="1800" b="1" dirty="0">
+                <a:solidFill>
+                  <a:srgbClr val="FFFEFA"/>
+                </a:solidFill>
+                <a:latin typeface="Georgia" pitchFamily="34" charset="0"/>
+                <a:ea typeface="Georgia" pitchFamily="34" charset="-122"/>
+                <a:cs typeface="Georgia" pitchFamily="34" charset="-120"/>
+              </a:rPr>
+              <a:t>1</a:t>
+            </a:r>
+            <a:endParaRPr lang="en-US" sz="1800" dirty="0"/>
+          </a:p>
+        </p:txBody>
+      </p:sp>
+      <p:sp>
+        <p:nvSpPr>
+          <p:cNvPr id="16" name="Text 13"/>
+          <p:cNvSpPr/>
+          <p:nvPr/>
+        </p:nvSpPr>
+        <p:spPr>
+          <a:xfrm>
+            <a:off x="3758184" y="2354580"/>
+            <a:ext cx="7747711" cy="731520"/>
           </a:xfrm>
           <a:prstGeom prst="rect">
             <a:avLst/>
@@ -6033,14 +6920,14 @@
       </p:sp>
       <p:sp>
         <p:nvSpPr>
-          <p:cNvPr id="8" name="Shape 5"/>
-          <p:cNvSpPr/>
-          <p:nvPr/>
-        </p:nvSpPr>
-        <p:spPr>
-          <a:xfrm>
-            <a:off x="3021439" y="3419856"/>
-            <a:ext cx="292608" cy="292608"/>
+          <p:cNvPr id="17" name="Shape 14"/>
+          <p:cNvSpPr/>
+          <p:nvPr/>
+        </p:nvSpPr>
+        <p:spPr>
+          <a:xfrm>
+            <a:off x="3118104" y="3223260"/>
+            <a:ext cx="457200" cy="457200"/>
           </a:xfrm>
           <a:prstGeom prst="ellipse">
             <a:avLst/>
@@ -6048,24 +6935,70 @@
           <a:solidFill>
             <a:srgbClr val="FC4540"/>
           </a:solidFill>
-          <a:ln w="12700">
-            <a:solidFill>
-              <a:srgbClr val="FC4540"/>
-            </a:solidFill>
-            <a:prstDash val="solid"/>
-          </a:ln>
-        </p:spPr>
-      </p:sp>
-      <p:sp>
-        <p:nvSpPr>
-          <p:cNvPr id="9" name="Text 6"/>
-          <p:cNvSpPr/>
-          <p:nvPr/>
-        </p:nvSpPr>
-        <p:spPr>
-          <a:xfrm>
-            <a:off x="3496927" y="3108960"/>
-            <a:ext cx="8008968" cy="914400"/>
+          <a:ln w="25400">
+            <a:solidFill>
+              <a:srgbClr val="FFFEFA"/>
+            </a:solidFill>
+            <a:prstDash val="solid"/>
+          </a:ln>
+          <a:effectLst>
+            <a:outerShdw sx="100000" sy="100000" kx="0" ky="0" algn="bl" rotWithShape="0" blurRad="50800" dist="19050" dir="5400000">
+              <a:srgbClr val="3C3828">
+                <a:alpha val="25000"/>
+              </a:srgbClr>
+            </a:outerShdw>
+          </a:effectLst>
+        </p:spPr>
+      </p:sp>
+      <p:sp>
+        <p:nvSpPr>
+          <p:cNvPr id="18" name="Text 15"/>
+          <p:cNvSpPr/>
+          <p:nvPr/>
+        </p:nvSpPr>
+        <p:spPr>
+          <a:xfrm>
+            <a:off x="3118104" y="3223260"/>
+            <a:ext cx="457200" cy="457200"/>
+          </a:xfrm>
+          <a:prstGeom prst="rect">
+            <a:avLst/>
+          </a:prstGeom>
+          <a:noFill/>
+          <a:ln/>
+        </p:spPr>
+        <p:txBody>
+          <a:bodyPr wrap="square" lIns="0" tIns="0" rIns="0" bIns="0" rtlCol="0" anchor="ctr"/>
+          <a:lstStyle/>
+          <a:p>
+            <a:pPr algn="ctr" indent="0" marL="0">
+              <a:buNone/>
+            </a:pPr>
+            <a:r>
+              <a:rPr lang="en-US" sz="1800" b="1" dirty="0">
+                <a:solidFill>
+                  <a:srgbClr val="FFFEFA"/>
+                </a:solidFill>
+                <a:latin typeface="Georgia" pitchFamily="34" charset="0"/>
+                <a:ea typeface="Georgia" pitchFamily="34" charset="-122"/>
+                <a:cs typeface="Georgia" pitchFamily="34" charset="-120"/>
+              </a:rPr>
+              <a:t>2</a:t>
+            </a:r>
+            <a:endParaRPr lang="en-US" sz="1800" dirty="0"/>
+          </a:p>
+        </p:txBody>
+      </p:sp>
+      <p:sp>
+        <p:nvSpPr>
+          <p:cNvPr id="19" name="Text 16"/>
+          <p:cNvSpPr/>
+          <p:nvPr/>
+        </p:nvSpPr>
+        <p:spPr>
+          <a:xfrm>
+            <a:off x="3758184" y="3086100"/>
+            <a:ext cx="7747711" cy="731520"/>
           </a:xfrm>
           <a:prstGeom prst="rect">
             <a:avLst/>
@@ -6122,14 +7055,14 @@
       </p:sp>
       <p:sp>
         <p:nvSpPr>
-          <p:cNvPr id="10" name="Shape 7"/>
-          <p:cNvSpPr/>
-          <p:nvPr/>
-        </p:nvSpPr>
-        <p:spPr>
-          <a:xfrm>
-            <a:off x="3021439" y="4334256"/>
-            <a:ext cx="292608" cy="292608"/>
+          <p:cNvPr id="20" name="Shape 17"/>
+          <p:cNvSpPr/>
+          <p:nvPr/>
+        </p:nvSpPr>
+        <p:spPr>
+          <a:xfrm>
+            <a:off x="3118104" y="3954780"/>
+            <a:ext cx="457200" cy="457200"/>
           </a:xfrm>
           <a:prstGeom prst="ellipse">
             <a:avLst/>
@@ -6137,24 +7070,70 @@
           <a:solidFill>
             <a:srgbClr val="FF9755"/>
           </a:solidFill>
-          <a:ln w="12700">
-            <a:solidFill>
-              <a:srgbClr val="FF9755"/>
-            </a:solidFill>
-            <a:prstDash val="solid"/>
-          </a:ln>
-        </p:spPr>
-      </p:sp>
-      <p:sp>
-        <p:nvSpPr>
-          <p:cNvPr id="11" name="Text 8"/>
-          <p:cNvSpPr/>
-          <p:nvPr/>
-        </p:nvSpPr>
-        <p:spPr>
-          <a:xfrm>
-            <a:off x="3496927" y="4023360"/>
-            <a:ext cx="8008968" cy="914400"/>
+          <a:ln w="25400">
+            <a:solidFill>
+              <a:srgbClr val="FFFEFA"/>
+            </a:solidFill>
+            <a:prstDash val="solid"/>
+          </a:ln>
+          <a:effectLst>
+            <a:outerShdw sx="100000" sy="100000" kx="0" ky="0" algn="bl" rotWithShape="0" blurRad="50800" dist="19050" dir="5400000">
+              <a:srgbClr val="3C3828">
+                <a:alpha val="25000"/>
+              </a:srgbClr>
+            </a:outerShdw>
+          </a:effectLst>
+        </p:spPr>
+      </p:sp>
+      <p:sp>
+        <p:nvSpPr>
+          <p:cNvPr id="21" name="Text 18"/>
+          <p:cNvSpPr/>
+          <p:nvPr/>
+        </p:nvSpPr>
+        <p:spPr>
+          <a:xfrm>
+            <a:off x="3118104" y="3954780"/>
+            <a:ext cx="457200" cy="457200"/>
+          </a:xfrm>
+          <a:prstGeom prst="rect">
+            <a:avLst/>
+          </a:prstGeom>
+          <a:noFill/>
+          <a:ln/>
+        </p:spPr>
+        <p:txBody>
+          <a:bodyPr wrap="square" lIns="0" tIns="0" rIns="0" bIns="0" rtlCol="0" anchor="ctr"/>
+          <a:lstStyle/>
+          <a:p>
+            <a:pPr algn="ctr" indent="0" marL="0">
+              <a:buNone/>
+            </a:pPr>
+            <a:r>
+              <a:rPr lang="en-US" sz="1800" b="1" dirty="0">
+                <a:solidFill>
+                  <a:srgbClr val="FFFEFA"/>
+                </a:solidFill>
+                <a:latin typeface="Georgia" pitchFamily="34" charset="0"/>
+                <a:ea typeface="Georgia" pitchFamily="34" charset="-122"/>
+                <a:cs typeface="Georgia" pitchFamily="34" charset="-120"/>
+              </a:rPr>
+              <a:t>3</a:t>
+            </a:r>
+            <a:endParaRPr lang="en-US" sz="1800" dirty="0"/>
+          </a:p>
+        </p:txBody>
+      </p:sp>
+      <p:sp>
+        <p:nvSpPr>
+          <p:cNvPr id="22" name="Text 19"/>
+          <p:cNvSpPr/>
+          <p:nvPr/>
+        </p:nvSpPr>
+        <p:spPr>
+          <a:xfrm>
+            <a:off x="3758184" y="3817620"/>
+            <a:ext cx="7747711" cy="731520"/>
           </a:xfrm>
           <a:prstGeom prst="rect">
             <a:avLst/>
@@ -6211,14 +7190,14 @@
       </p:sp>
       <p:sp>
         <p:nvSpPr>
-          <p:cNvPr id="12" name="Shape 9"/>
-          <p:cNvSpPr/>
-          <p:nvPr/>
-        </p:nvSpPr>
-        <p:spPr>
-          <a:xfrm>
-            <a:off x="3021439" y="5248656"/>
-            <a:ext cx="292608" cy="292608"/>
+          <p:cNvPr id="23" name="Shape 20"/>
+          <p:cNvSpPr/>
+          <p:nvPr/>
+        </p:nvSpPr>
+        <p:spPr>
+          <a:xfrm>
+            <a:off x="3118104" y="4686300"/>
+            <a:ext cx="457200" cy="457200"/>
           </a:xfrm>
           <a:prstGeom prst="ellipse">
             <a:avLst/>
@@ -6226,24 +7205,70 @@
           <a:solidFill>
             <a:srgbClr val="FC4067"/>
           </a:solidFill>
-          <a:ln w="12700">
-            <a:solidFill>
-              <a:srgbClr val="FC4067"/>
-            </a:solidFill>
-            <a:prstDash val="solid"/>
-          </a:ln>
-        </p:spPr>
-      </p:sp>
-      <p:sp>
-        <p:nvSpPr>
-          <p:cNvPr id="13" name="Text 10"/>
-          <p:cNvSpPr/>
-          <p:nvPr/>
-        </p:nvSpPr>
-        <p:spPr>
-          <a:xfrm>
-            <a:off x="3496927" y="4937760"/>
-            <a:ext cx="8008968" cy="914400"/>
+          <a:ln w="25400">
+            <a:solidFill>
+              <a:srgbClr val="FFFEFA"/>
+            </a:solidFill>
+            <a:prstDash val="solid"/>
+          </a:ln>
+          <a:effectLst>
+            <a:outerShdw sx="100000" sy="100000" kx="0" ky="0" algn="bl" rotWithShape="0" blurRad="50800" dist="19050" dir="5400000">
+              <a:srgbClr val="3C3828">
+                <a:alpha val="25000"/>
+              </a:srgbClr>
+            </a:outerShdw>
+          </a:effectLst>
+        </p:spPr>
+      </p:sp>
+      <p:sp>
+        <p:nvSpPr>
+          <p:cNvPr id="24" name="Text 21"/>
+          <p:cNvSpPr/>
+          <p:nvPr/>
+        </p:nvSpPr>
+        <p:spPr>
+          <a:xfrm>
+            <a:off x="3118104" y="4686300"/>
+            <a:ext cx="457200" cy="457200"/>
+          </a:xfrm>
+          <a:prstGeom prst="rect">
+            <a:avLst/>
+          </a:prstGeom>
+          <a:noFill/>
+          <a:ln/>
+        </p:spPr>
+        <p:txBody>
+          <a:bodyPr wrap="square" lIns="0" tIns="0" rIns="0" bIns="0" rtlCol="0" anchor="ctr"/>
+          <a:lstStyle/>
+          <a:p>
+            <a:pPr algn="ctr" indent="0" marL="0">
+              <a:buNone/>
+            </a:pPr>
+            <a:r>
+              <a:rPr lang="en-US" sz="1800" b="1" dirty="0">
+                <a:solidFill>
+                  <a:srgbClr val="FFFEFA"/>
+                </a:solidFill>
+                <a:latin typeface="Georgia" pitchFamily="34" charset="0"/>
+                <a:ea typeface="Georgia" pitchFamily="34" charset="-122"/>
+                <a:cs typeface="Georgia" pitchFamily="34" charset="-120"/>
+              </a:rPr>
+              <a:t>4</a:t>
+            </a:r>
+            <a:endParaRPr lang="en-US" sz="1800" dirty="0"/>
+          </a:p>
+        </p:txBody>
+      </p:sp>
+      <p:sp>
+        <p:nvSpPr>
+          <p:cNvPr id="25" name="Text 22"/>
+          <p:cNvSpPr/>
+          <p:nvPr/>
+        </p:nvSpPr>
+        <p:spPr>
+          <a:xfrm>
+            <a:off x="3758184" y="4549140"/>
+            <a:ext cx="7747711" cy="731520"/>
           </a:xfrm>
           <a:prstGeom prst="rect">
             <a:avLst/>
@@ -6368,7 +7393,7 @@
         </p:nvSpPr>
         <p:spPr>
           <a:xfrm>
-            <a:off x="685800" y="502920"/>
+            <a:off x="685800" y="274320"/>
             <a:ext cx="9357055" cy="320040"/>
           </a:xfrm>
           <a:prstGeom prst="rect">
@@ -6407,8 +7432,8 @@
         </p:nvSpPr>
         <p:spPr>
           <a:xfrm>
-            <a:off x="685800" y="868680"/>
-            <a:ext cx="9357055" cy="960120"/>
+            <a:off x="685800" y="621792"/>
+            <a:ext cx="9357055" cy="640080"/>
           </a:xfrm>
           <a:prstGeom prst="rect">
             <a:avLst/>
@@ -6424,7 +7449,7 @@
               <a:buNone/>
             </a:pPr>
             <a:r>
-              <a:rPr lang="en-US" sz="3600" dirty="0">
+              <a:rPr lang="en-US" sz="3200" dirty="0">
                 <a:solidFill>
                   <a:srgbClr val="3C3828"/>
                 </a:solidFill>
@@ -6434,7 +7459,7 @@
               </a:rPr>
               <a:t>Your YAWP! dashboard</a:t>
             </a:r>
-            <a:endParaRPr lang="en-US" sz="3600" dirty="0"/>
+            <a:endParaRPr lang="en-US" sz="3200" dirty="0"/>
           </a:p>
         </p:txBody>
       </p:sp>
@@ -6446,12 +7471,12 @@
         </p:nvSpPr>
         <p:spPr>
           <a:xfrm>
-            <a:off x="685800" y="1828800"/>
-            <a:ext cx="6949440" cy="4283901"/>
+            <a:off x="685800" y="1525451"/>
+            <a:ext cx="7436815" cy="4584338"/>
           </a:xfrm>
           <a:prstGeom prst="roundRect">
             <a:avLst>
-              <a:gd name="adj" fmla="val 2988"/>
+              <a:gd name="adj" fmla="val 2792"/>
             </a:avLst>
           </a:prstGeom>
           <a:solidFill>
@@ -6488,8 +7513,8 @@
         </p:blipFill>
         <p:spPr>
           <a:xfrm>
-            <a:off x="813816" y="1956816"/>
-            <a:ext cx="6693408" cy="4027869"/>
+            <a:off x="813816" y="1653467"/>
+            <a:ext cx="7180783" cy="4328306"/>
           </a:xfrm>
           <a:prstGeom prst="rect">
             <a:avLst/>
@@ -6504,7 +7529,7 @@
         </p:nvSpPr>
         <p:spPr>
           <a:xfrm>
-            <a:off x="8183880" y="2505456"/>
+            <a:off x="8579815" y="2330196"/>
             <a:ext cx="292608" cy="292608"/>
           </a:xfrm>
           <a:prstGeom prst="ellipse">
@@ -6529,8 +7554,8 @@
         </p:nvSpPr>
         <p:spPr>
           <a:xfrm>
-            <a:off x="8659368" y="2194560"/>
-            <a:ext cx="2846527" cy="914400"/>
+            <a:off x="9055303" y="2029460"/>
+            <a:ext cx="2450592" cy="894080"/>
           </a:xfrm>
           <a:prstGeom prst="rect">
             <a:avLst/>
@@ -6568,7 +7593,7 @@
         </p:nvSpPr>
         <p:spPr>
           <a:xfrm>
-            <a:off x="8183880" y="3419856"/>
+            <a:off x="8579815" y="3224276"/>
             <a:ext cx="292608" cy="292608"/>
           </a:xfrm>
           <a:prstGeom prst="ellipse">
@@ -6593,8 +7618,8 @@
         </p:nvSpPr>
         <p:spPr>
           <a:xfrm>
-            <a:off x="8659368" y="3108960"/>
-            <a:ext cx="2846527" cy="914400"/>
+            <a:off x="9055303" y="2923540"/>
+            <a:ext cx="2450592" cy="894080"/>
           </a:xfrm>
           <a:prstGeom prst="rect">
             <a:avLst/>
@@ -6632,7 +7657,7 @@
         </p:nvSpPr>
         <p:spPr>
           <a:xfrm>
-            <a:off x="8183880" y="4334256"/>
+            <a:off x="8579815" y="4118356"/>
             <a:ext cx="292608" cy="292608"/>
           </a:xfrm>
           <a:prstGeom prst="ellipse">
@@ -6657,8 +7682,8 @@
         </p:nvSpPr>
         <p:spPr>
           <a:xfrm>
-            <a:off x="8659368" y="4023360"/>
-            <a:ext cx="2846527" cy="914400"/>
+            <a:off x="9055303" y="3817620"/>
+            <a:ext cx="2450592" cy="894080"/>
           </a:xfrm>
           <a:prstGeom prst="rect">
             <a:avLst/>
@@ -6696,7 +7721,7 @@
         </p:nvSpPr>
         <p:spPr>
           <a:xfrm>
-            <a:off x="8183880" y="5248656"/>
+            <a:off x="8579815" y="5012436"/>
             <a:ext cx="292608" cy="292608"/>
           </a:xfrm>
           <a:prstGeom prst="ellipse">
@@ -6721,8 +7746,8 @@
         </p:nvSpPr>
         <p:spPr>
           <a:xfrm>
-            <a:off x="8659368" y="4937760"/>
-            <a:ext cx="2846527" cy="914400"/>
+            <a:off x="9055303" y="4711700"/>
+            <a:ext cx="2450592" cy="894080"/>
           </a:xfrm>
           <a:prstGeom prst="rect">
             <a:avLst/>
@@ -6820,6 +7845,507 @@
             <a:fld id="{F7021451-1387-4CA6-816F-3879F97B5CBC}" type="slidenum">
               <a:rPr b="0" lang="en-US"/>
               <a:t>15</a:t>
+            </a:fld>
+            <a:endParaRPr lang="en-US"/>
+          </a:p>
+        </p:txBody>
+      </p:sp>
+    </p:spTree>
+  </p:cSld>
+  <p:clrMapOvr>
+    <a:masterClrMapping/>
+  </p:clrMapOvr>
+</p:sld>
+</file>
+
+<file path=ppt/slides/slide16.xml><?xml version="1.0" encoding="utf-8"?>
+<p:sld xmlns:a="http://schemas.openxmlformats.org/drawingml/2006/main" xmlns:r="http://schemas.openxmlformats.org/officeDocument/2006/relationships" xmlns:p="http://schemas.openxmlformats.org/presentationml/2006/main">
+  <p:cSld name="Slide 16">
+    <p:bg>
+      <p:bgPr>
+        <a:solidFill>
+          <a:srgbClr val="02BDC7"/>
+        </a:solidFill>
+      </p:bgPr>
+    </p:bg>
+    <p:spTree>
+      <p:nvGrpSpPr>
+        <p:cNvPr id="1" name=""/>
+        <p:cNvGrpSpPr/>
+        <p:nvPr/>
+      </p:nvGrpSpPr>
+      <p:grpSpPr>
+        <a:xfrm>
+          <a:off x="0" y="0"/>
+          <a:ext cx="0" cy="0"/>
+          <a:chOff x="0" y="0"/>
+          <a:chExt cx="0" cy="0"/>
+        </a:xfrm>
+      </p:grpSpPr>
+      <p:sp>
+        <p:nvSpPr>
+          <p:cNvPr id="2" name="Shape 0"/>
+          <p:cNvSpPr/>
+          <p:nvPr/>
+        </p:nvSpPr>
+        <p:spPr>
+          <a:xfrm>
+            <a:off x="4175608" y="1234440"/>
+            <a:ext cx="3840480" cy="3840480"/>
+          </a:xfrm>
+          <a:prstGeom prst="ellipse">
+            <a:avLst/>
+          </a:prstGeom>
+          <a:solidFill>
+            <a:srgbClr val="FFFEFA"/>
+          </a:solidFill>
+          <a:ln w="12700">
+            <a:solidFill>
+              <a:srgbClr val="FFFEFA"/>
+            </a:solidFill>
+            <a:prstDash val="solid"/>
+          </a:ln>
+          <a:effectLst>
+            <a:outerShdw sx="100000" sy="100000" kx="0" ky="0" algn="bl" rotWithShape="0" blurRad="177800" dist="50800" dir="5400000">
+              <a:srgbClr val="3C3828">
+                <a:alpha val="18000"/>
+              </a:srgbClr>
+            </a:outerShdw>
+          </a:effectLst>
+        </p:spPr>
+      </p:sp>
+      <p:sp>
+        <p:nvSpPr>
+          <p:cNvPr id="3" name="Text 1"/>
+          <p:cNvSpPr/>
+          <p:nvPr/>
+        </p:nvSpPr>
+        <p:spPr>
+          <a:xfrm>
+            <a:off x="4175608" y="2377440"/>
+            <a:ext cx="3840480" cy="1097280"/>
+          </a:xfrm>
+          <a:prstGeom prst="rect">
+            <a:avLst/>
+          </a:prstGeom>
+          <a:noFill/>
+          <a:ln/>
+        </p:spPr>
+        <p:txBody>
+          <a:bodyPr wrap="square" lIns="0" tIns="0" rIns="0" bIns="0" rtlCol="0" anchor="ctr"/>
+          <a:lstStyle/>
+          <a:p>
+            <a:pPr algn="ctr" indent="0" marL="0">
+              <a:buNone/>
+            </a:pPr>
+            <a:r>
+              <a:rPr lang="en-US" sz="7200" b="1" dirty="0">
+                <a:solidFill>
+                  <a:srgbClr val="3C3828"/>
+                </a:solidFill>
+                <a:latin typeface="Georgia" pitchFamily="34" charset="0"/>
+                <a:ea typeface="Georgia" pitchFamily="34" charset="-122"/>
+                <a:cs typeface="Georgia" pitchFamily="34" charset="-120"/>
+              </a:rPr>
+              <a:t>YAWP!</a:t>
+            </a:r>
+            <a:endParaRPr lang="en-US" sz="7200" dirty="0"/>
+          </a:p>
+        </p:txBody>
+      </p:sp>
+      <p:sp>
+        <p:nvSpPr>
+          <p:cNvPr id="4" name="Text 2"/>
+          <p:cNvSpPr/>
+          <p:nvPr/>
+        </p:nvSpPr>
+        <p:spPr>
+          <a:xfrm>
+            <a:off x="4175608" y="3520440"/>
+            <a:ext cx="3840480" cy="365760"/>
+          </a:xfrm>
+          <a:prstGeom prst="rect">
+            <a:avLst/>
+          </a:prstGeom>
+          <a:noFill/>
+          <a:ln/>
+        </p:spPr>
+        <p:txBody>
+          <a:bodyPr wrap="square" lIns="0" tIns="0" rIns="0" bIns="0" rtlCol="0" anchor="ctr"/>
+          <a:lstStyle/>
+          <a:p>
+            <a:pPr algn="ctr" indent="0" marL="0">
+              <a:buNone/>
+            </a:pPr>
+            <a:r>
+              <a:rPr lang="en-US" sz="1300" b="1" spc="300" kern="0" dirty="0">
+                <a:solidFill>
+                  <a:srgbClr val="D27151"/>
+                </a:solidFill>
+                <a:latin typeface="Consolas" pitchFamily="34" charset="0"/>
+                <a:ea typeface="Consolas" pitchFamily="34" charset="-122"/>
+                <a:cs typeface="Consolas" pitchFamily="34" charset="-120"/>
+              </a:rPr>
+              <a:t>WRITING PROGRAM</a:t>
+            </a:r>
+            <a:endParaRPr lang="en-US" sz="1300" dirty="0"/>
+          </a:p>
+        </p:txBody>
+      </p:sp>
+      <p:sp>
+        <p:nvSpPr>
+          <p:cNvPr id="5" name="Shape 3"/>
+          <p:cNvSpPr/>
+          <p:nvPr/>
+        </p:nvSpPr>
+        <p:spPr>
+          <a:xfrm>
+            <a:off x="6918808" y="777240"/>
+            <a:ext cx="1463040" cy="1463040"/>
+          </a:xfrm>
+          <a:prstGeom prst="ellipse">
+            <a:avLst/>
+          </a:prstGeom>
+          <a:solidFill>
+            <a:srgbClr val="FFB600"/>
+          </a:solidFill>
+          <a:ln w="12700">
+            <a:solidFill>
+              <a:srgbClr val="FFB600"/>
+            </a:solidFill>
+            <a:prstDash val="solid"/>
+          </a:ln>
+        </p:spPr>
+      </p:sp>
+      <p:pic>
+        <p:nvPicPr>
+          <p:cNvPr id="6" name="Image 0" descr="lightbulb icon">    </p:cNvPr>
+          <p:cNvPicPr>
+            <a:picLocks noChangeAspect="1"/>
+          </p:cNvPicPr>
+          <p:nvPr/>
+        </p:nvPicPr>
+        <p:blipFill>
+          <a:blip r:embed="rId1"/>
+          <a:stretch>
+            <a:fillRect/>
+          </a:stretch>
+        </p:blipFill>
+        <p:spPr>
+          <a:xfrm>
+            <a:off x="7211416" y="1069848"/>
+            <a:ext cx="877824" cy="877824"/>
+          </a:xfrm>
+          <a:prstGeom prst="rect">
+            <a:avLst/>
+          </a:prstGeom>
+        </p:spPr>
+      </p:pic>
+      <p:sp>
+        <p:nvSpPr>
+          <p:cNvPr id="7" name="Shape 4"/>
+          <p:cNvSpPr/>
+          <p:nvPr/>
+        </p:nvSpPr>
+        <p:spPr>
+          <a:xfrm>
+            <a:off x="3626968" y="1508760"/>
+            <a:ext cx="1005840" cy="1005840"/>
+          </a:xfrm>
+          <a:prstGeom prst="ellipse">
+            <a:avLst/>
+          </a:prstGeom>
+          <a:solidFill>
+            <a:srgbClr val="FF9755"/>
+          </a:solidFill>
+          <a:ln w="12700">
+            <a:solidFill>
+              <a:srgbClr val="FF9755"/>
+            </a:solidFill>
+            <a:prstDash val="solid"/>
+          </a:ln>
+        </p:spPr>
+      </p:sp>
+      <p:pic>
+        <p:nvPicPr>
+          <p:cNvPr id="8" name="Image 1" descr="puzzle icon">    </p:cNvPr>
+          <p:cNvPicPr>
+            <a:picLocks noChangeAspect="1"/>
+          </p:cNvPicPr>
+          <p:nvPr/>
+        </p:nvPicPr>
+        <p:blipFill>
+          <a:blip r:embed="rId2"/>
+          <a:stretch>
+            <a:fillRect/>
+          </a:stretch>
+        </p:blipFill>
+        <p:spPr>
+          <a:xfrm>
+            <a:off x="3828136" y="1709928"/>
+            <a:ext cx="603504" cy="603504"/>
+          </a:xfrm>
+          <a:prstGeom prst="rect">
+            <a:avLst/>
+          </a:prstGeom>
+        </p:spPr>
+      </p:pic>
+      <p:sp>
+        <p:nvSpPr>
+          <p:cNvPr id="9" name="Shape 5"/>
+          <p:cNvSpPr/>
+          <p:nvPr/>
+        </p:nvSpPr>
+        <p:spPr>
+          <a:xfrm>
+            <a:off x="4267048" y="4069080"/>
+            <a:ext cx="1188720" cy="1188720"/>
+          </a:xfrm>
+          <a:prstGeom prst="ellipse">
+            <a:avLst/>
+          </a:prstGeom>
+          <a:solidFill>
+            <a:srgbClr val="FC4540"/>
+          </a:solidFill>
+          <a:ln w="12700">
+            <a:solidFill>
+              <a:srgbClr val="FC4540"/>
+            </a:solidFill>
+            <a:prstDash val="solid"/>
+          </a:ln>
+        </p:spPr>
+      </p:sp>
+      <p:pic>
+        <p:nvPicPr>
+          <p:cNvPr id="10" name="Image 2" descr="thumbs icon">    </p:cNvPr>
+          <p:cNvPicPr>
+            <a:picLocks noChangeAspect="1"/>
+          </p:cNvPicPr>
+          <p:nvPr/>
+        </p:nvPicPr>
+        <p:blipFill>
+          <a:blip r:embed="rId3"/>
+          <a:stretch>
+            <a:fillRect/>
+          </a:stretch>
+        </p:blipFill>
+        <p:spPr>
+          <a:xfrm>
+            <a:off x="4504792" y="4306824"/>
+            <a:ext cx="713232" cy="713232"/>
+          </a:xfrm>
+          <a:prstGeom prst="rect">
+            <a:avLst/>
+          </a:prstGeom>
+        </p:spPr>
+      </p:pic>
+      <p:sp>
+        <p:nvSpPr>
+          <p:cNvPr id="11" name="Shape 6"/>
+          <p:cNvSpPr/>
+          <p:nvPr/>
+        </p:nvSpPr>
+        <p:spPr>
+          <a:xfrm>
+            <a:off x="3855568" y="2971800"/>
+            <a:ext cx="274320" cy="274320"/>
+          </a:xfrm>
+          <a:prstGeom prst="ellipse">
+            <a:avLst/>
+          </a:prstGeom>
+          <a:solidFill>
+            <a:srgbClr val="FFFEFA"/>
+          </a:solidFill>
+          <a:ln w="12700">
+            <a:solidFill>
+              <a:srgbClr val="FFFEFA"/>
+            </a:solidFill>
+            <a:prstDash val="solid"/>
+          </a:ln>
+        </p:spPr>
+      </p:sp>
+      <p:sp>
+        <p:nvSpPr>
+          <p:cNvPr id="12" name="Shape 7"/>
+          <p:cNvSpPr/>
+          <p:nvPr/>
+        </p:nvSpPr>
+        <p:spPr>
+          <a:xfrm>
+            <a:off x="8107528" y="2606040"/>
+            <a:ext cx="411480" cy="411480"/>
+          </a:xfrm>
+          <a:prstGeom prst="ellipse">
+            <a:avLst/>
+          </a:prstGeom>
+          <a:solidFill>
+            <a:srgbClr val="FC4067"/>
+          </a:solidFill>
+          <a:ln w="12700">
+            <a:solidFill>
+              <a:srgbClr val="FC4067"/>
+            </a:solidFill>
+            <a:prstDash val="solid"/>
+          </a:ln>
+        </p:spPr>
+      </p:sp>
+      <p:sp>
+        <p:nvSpPr>
+          <p:cNvPr id="13" name="Shape 8"/>
+          <p:cNvSpPr/>
+          <p:nvPr/>
+        </p:nvSpPr>
+        <p:spPr>
+          <a:xfrm>
+            <a:off x="7558888" y="5120640"/>
+            <a:ext cx="548640" cy="548640"/>
+          </a:xfrm>
+          <a:prstGeom prst="ellipse">
+            <a:avLst/>
+          </a:prstGeom>
+          <a:solidFill>
+            <a:srgbClr val="FF9755"/>
+          </a:solidFill>
+          <a:ln w="12700">
+            <a:solidFill>
+              <a:srgbClr val="FF9755"/>
+            </a:solidFill>
+            <a:prstDash val="solid"/>
+          </a:ln>
+        </p:spPr>
+      </p:sp>
+      <p:sp>
+        <p:nvSpPr>
+          <p:cNvPr id="14" name="Shape 9"/>
+          <p:cNvSpPr/>
+          <p:nvPr/>
+        </p:nvSpPr>
+        <p:spPr>
+          <a:xfrm>
+            <a:off x="6735928" y="5349240"/>
+            <a:ext cx="164592" cy="164592"/>
+          </a:xfrm>
+          <a:prstGeom prst="ellipse">
+            <a:avLst/>
+          </a:prstGeom>
+          <a:solidFill>
+            <a:srgbClr val="FFB600"/>
+          </a:solidFill>
+          <a:ln w="12700">
+            <a:solidFill>
+              <a:srgbClr val="FFB600"/>
+            </a:solidFill>
+            <a:prstDash val="solid"/>
+          </a:ln>
+        </p:spPr>
+      </p:sp>
+      <p:sp>
+        <p:nvSpPr>
+          <p:cNvPr id="15" name="Shape 10"/>
+          <p:cNvSpPr/>
+          <p:nvPr/>
+        </p:nvSpPr>
+        <p:spPr>
+          <a:xfrm>
+            <a:off x="5455768" y="5257800"/>
+            <a:ext cx="201168" cy="201168"/>
+          </a:xfrm>
+          <a:prstGeom prst="ellipse">
+            <a:avLst/>
+          </a:prstGeom>
+          <a:solidFill>
+            <a:srgbClr val="FFFEFA"/>
+          </a:solidFill>
+          <a:ln w="12700">
+            <a:solidFill>
+              <a:srgbClr val="FFFEFA"/>
+            </a:solidFill>
+            <a:prstDash val="solid"/>
+          </a:ln>
+        </p:spPr>
+      </p:sp>
+      <p:sp>
+        <p:nvSpPr>
+          <p:cNvPr id="16" name="Text 11"/>
+          <p:cNvSpPr/>
+          <p:nvPr/>
+        </p:nvSpPr>
+        <p:spPr>
+          <a:xfrm>
+            <a:off x="685800" y="5577840"/>
+            <a:ext cx="10820095" cy="548640"/>
+          </a:xfrm>
+          <a:prstGeom prst="rect">
+            <a:avLst/>
+          </a:prstGeom>
+          <a:noFill/>
+          <a:ln/>
+        </p:spPr>
+        <p:txBody>
+          <a:bodyPr wrap="square" lIns="0" tIns="0" rIns="0" bIns="0" rtlCol="0" anchor="ctr"/>
+          <a:lstStyle/>
+          <a:p>
+            <a:pPr algn="ctr" indent="0" marL="0">
+              <a:buNone/>
+            </a:pPr>
+            <a:r>
+              <a:rPr lang="en-US" sz="2200" dirty="0">
+                <a:solidFill>
+                  <a:srgbClr val="FFFEFA"/>
+                </a:solidFill>
+                <a:latin typeface="Calibri" pitchFamily="34" charset="0"/>
+                <a:ea typeface="Calibri" pitchFamily="34" charset="-122"/>
+                <a:cs typeface="Calibri" pitchFamily="34" charset="-120"/>
+              </a:rPr>
+              <a:t>Next time: pre-writing.</a:t>
+            </a:r>
+            <a:endParaRPr lang="en-US" sz="2200" dirty="0"/>
+          </a:p>
+        </p:txBody>
+      </p:sp>
+      <p:sp>
+        <p:nvSpPr>
+          <p:cNvPr id="25" name="Slide Number Placeholder 0"/>
+          <p:cNvSpPr>
+            <a:spLocks noGrp="1"/>
+          </p:cNvSpPr>
+          <p:nvPr>
+            <p:ph type="sldNum" sz="quarter" idx="4294967295"/>
+          </p:nvPr>
+        </p:nvSpPr>
+        <p:spPr>
+          <a:xfrm>
+            <a:off x="10957255" y="6355080"/>
+            <a:ext cx="548640" cy="320040"/>
+          </a:xfrm>
+          <a:prstGeom prst="rect">
+            <a:avLst/>
+          </a:prstGeom>
+          <a:extLst>
+            <a:ext uri="{C572A759-6A51-4108-AA02-DFA0A04FC94B}">
+              <ma14:wrappingTextBoxFlag xmlns:ma14="http://schemas.microsoft.com/office/mac/drawingml/2011/main" val="0"/>
+            </a:ext>
+          </a:extLst>
+        </p:spPr>
+        <p:txBody>
+          <a:bodyPr/>
+          <a:lstStyle>
+            <a:lvl1pPr>
+              <a:defRPr sz="1000">
+                <a:solidFill>
+                  <a:srgbClr val="7E7C78"/>
+                </a:solidFill>
+                <a:latin typeface="Consolas"/>
+                <a:ea typeface="Consolas"/>
+                <a:cs typeface="Consolas"/>
+              </a:defRPr>
+            </a:lvl1pPr>
+          </a:lstStyle>
+          <a:p>
+            <a:pPr algn="r"/>
+            <a:fld id="{F7021451-1387-4CA6-816F-3879F97B5CBC}" type="slidenum">
+              <a:rPr b="0" lang="en-US"/>
+              <a:t>16</a:t>
             </a:fld>
             <a:endParaRPr lang="en-US"/>
           </a:p>
@@ -6922,7 +8448,7 @@
                 <a:ea typeface="Georgia" pitchFamily="34" charset="-122"/>
                 <a:cs typeface="Georgia" pitchFamily="34" charset="-120"/>
               </a:rPr>
-              <a:t>2 Truths and a Lie</a:t>
+              <a:t>2 Truths and a Lie</a:t>
             </a:r>
             <a:endParaRPr lang="en-US" sz="3600" dirty="0"/>
           </a:p>
@@ -7264,7 +8790,7 @@
               <a:buNone/>
             </a:pPr>
             <a:r>
-              <a:rPr lang="en-US" sz="2600" dirty="0">
+              <a:rPr lang="en-US" sz="2800" dirty="0">
                 <a:solidFill>
                   <a:srgbClr val="3C3828"/>
                 </a:solidFill>
@@ -7274,7 +8800,7 @@
               </a:rPr>
               <a:t>I have a twin who is a blonde-haired version of me.</a:t>
             </a:r>
-            <a:endParaRPr lang="en-US" sz="2600" dirty="0"/>
+            <a:endParaRPr lang="en-US" sz="2800" dirty="0"/>
           </a:p>
         </p:txBody>
       </p:sp>
@@ -7426,7 +8952,7 @@
               <a:buNone/>
             </a:pPr>
             <a:r>
-              <a:rPr lang="en-US" sz="2600" dirty="0">
+              <a:rPr lang="en-US" sz="2800" dirty="0">
                 <a:solidFill>
                   <a:srgbClr val="3C3828"/>
                 </a:solidFill>
@@ -7436,7 +8962,7 @@
               </a:rPr>
               <a:t>I was born in Canada.</a:t>
             </a:r>
-            <a:endParaRPr lang="en-US" sz="2600" dirty="0"/>
+            <a:endParaRPr lang="en-US" sz="2800" dirty="0"/>
           </a:p>
         </p:txBody>
       </p:sp>
@@ -7588,7 +9114,7 @@
               <a:buNone/>
             </a:pPr>
             <a:r>
-              <a:rPr lang="en-US" sz="2600" dirty="0">
+              <a:rPr lang="en-US" sz="2800" dirty="0">
                 <a:solidFill>
                   <a:srgbClr val="3C3828"/>
                 </a:solidFill>
@@ -7598,7 +9124,7 @@
               </a:rPr>
               <a:t>I met my wife in high school.</a:t>
             </a:r>
-            <a:endParaRPr lang="en-US" sz="2600" dirty="0"/>
+            <a:endParaRPr lang="en-US" sz="2800" dirty="0"/>
           </a:p>
         </p:txBody>
       </p:sp>
@@ -7747,7 +9273,7 @@
                 <a:ea typeface="Georgia" pitchFamily="34" charset="-122"/>
                 <a:cs typeface="Georgia" pitchFamily="34" charset="-120"/>
               </a:rPr>
-              <a:t>I am Brian Connell</a:t>
+              <a:t>I am Brian Connell</a:t>
             </a:r>
             <a:endParaRPr lang="en-US" sz="3600" dirty="0"/>
           </a:p>
@@ -8001,7 +9527,7 @@
                 <a:ea typeface="Georgia" pitchFamily="34" charset="-122"/>
                 <a:cs typeface="Georgia" pitchFamily="34" charset="-120"/>
               </a:rPr>
-              <a:t>I am also Brian Connell</a:t>
+              <a:t>I am also Brian Connell</a:t>
             </a:r>
             <a:endParaRPr lang="en-US" sz="3600" dirty="0"/>
           </a:p>
@@ -8410,7 +9936,7 @@
                 <a:ea typeface="Georgia" pitchFamily="34" charset="-122"/>
                 <a:cs typeface="Georgia" pitchFamily="34" charset="-120"/>
               </a:rPr>
-              <a:t>the lie has to be believable!</a:t>
+              <a:t>the lie has to be believable!</a:t>
             </a:r>
             <a:endParaRPr lang="en-US" sz="4000" dirty="0"/>
           </a:p>
@@ -9115,7 +10641,7 @@
                 <a:ea typeface="Georgia" pitchFamily="34" charset="-122"/>
                 <a:cs typeface="Georgia" pitchFamily="34" charset="-120"/>
               </a:rPr>
-              <a:t>What do you think “yawp” means?</a:t>
+              <a:t>What do you think “yawp” means?</a:t>
             </a:r>
             <a:endParaRPr lang="en-US" sz="3600" dirty="0"/>
           </a:p>
@@ -9247,7 +10773,7 @@
               <a:buNone/>
             </a:pPr>
             <a:r>
-              <a:rPr lang="en-US" sz="2600" i="1" dirty="0">
+              <a:rPr lang="en-US" sz="3000" i="1" dirty="0">
                 <a:solidFill>
                   <a:srgbClr val="3C3828"/>
                 </a:solidFill>
@@ -9255,9 +10781,9 @@
                 <a:ea typeface="Georgia" pitchFamily="34" charset="-122"/>
                 <a:cs typeface="Georgia" pitchFamily="34" charset="-120"/>
               </a:rPr>
-              <a:t>I sound my barbaric yawp over the roofs of the world.</a:t>
-            </a:r>
-            <a:endParaRPr lang="en-US" sz="2600" dirty="0"/>
+              <a:t>I sound my barbaric yawp over the roofs of the world.</a:t>
+            </a:r>
+            <a:endParaRPr lang="en-US" sz="3000" dirty="0"/>
           </a:p>
         </p:txBody>
       </p:sp>
@@ -9445,7 +10971,7 @@
                 <a:ea typeface="Georgia" pitchFamily="34" charset="-122"/>
                 <a:cs typeface="Georgia" pitchFamily="34" charset="-120"/>
               </a:rPr>
-              <a:t>Why do we write?</a:t>
+              <a:t>Why do we write?</a:t>
             </a:r>
             <a:endParaRPr lang="en-US" sz="3600" dirty="0"/>
           </a:p>
@@ -9558,8 +11084,8 @@
         </p:nvSpPr>
         <p:spPr>
           <a:xfrm>
-            <a:off x="685800" y="1965960"/>
-            <a:ext cx="3393338" cy="3749040"/>
+            <a:off x="685800" y="2063496"/>
+            <a:ext cx="3393338" cy="3919728"/>
           </a:xfrm>
           <a:prstGeom prst="roundRect">
             <a:avLst>
@@ -9592,7 +11118,7 @@
         </p:nvSpPr>
         <p:spPr>
           <a:xfrm>
-            <a:off x="813816" y="1965960"/>
+            <a:off x="813816" y="2063496"/>
             <a:ext cx="3137306" cy="91440"/>
           </a:xfrm>
           <a:prstGeom prst="rect">
@@ -9617,7 +11143,7 @@
         </p:nvSpPr>
         <p:spPr>
           <a:xfrm>
-            <a:off x="1005840" y="2331720"/>
+            <a:off x="1005840" y="2429256"/>
             <a:ext cx="731520" cy="731520"/>
           </a:xfrm>
           <a:prstGeom prst="ellipse">
@@ -9642,7 +11168,7 @@
         </p:nvSpPr>
         <p:spPr>
           <a:xfrm>
-            <a:off x="1005840" y="2331720"/>
+            <a:off x="1005840" y="2429256"/>
             <a:ext cx="731520" cy="731520"/>
           </a:xfrm>
           <a:prstGeom prst="rect">
@@ -9681,8 +11207,8 @@
         </p:nvSpPr>
         <p:spPr>
           <a:xfrm>
-            <a:off x="1005840" y="3246120"/>
-            <a:ext cx="2753258" cy="2286000"/>
+            <a:off x="1005840" y="3343656"/>
+            <a:ext cx="2753258" cy="2456688"/>
           </a:xfrm>
           <a:prstGeom prst="rect">
             <a:avLst/>
@@ -9698,7 +11224,7 @@
               <a:buNone/>
             </a:pPr>
             <a:r>
-              <a:rPr lang="en-US" sz="2100" dirty="0">
+              <a:rPr lang="en-US" sz="2200" dirty="0">
                 <a:solidFill>
                   <a:srgbClr val="3C3828"/>
                 </a:solidFill>
@@ -9709,7 +11235,7 @@
               <a:t>Because we have </a:t>
             </a:r>
             <a:r>
-              <a:rPr lang="en-US" sz="2100" dirty="0">
+              <a:rPr lang="en-US" sz="2200" dirty="0">
                 <a:solidFill>
                   <a:srgbClr val="3C3828"/>
                 </a:solidFill>
@@ -9723,7 +11249,7 @@
               <a:t>things to say!</a:t>
             </a:r>
             <a:r>
-              <a:rPr lang="en-US" sz="2100" dirty="0">
+              <a:rPr lang="en-US" sz="2200" dirty="0">
                 <a:solidFill>
                   <a:srgbClr val="3C3828"/>
                 </a:solidFill>
@@ -9733,7 +11259,7 @@
               </a:rPr>
               <a:t> (Our individual “yawp.”)</a:t>
             </a:r>
-            <a:endParaRPr lang="en-US" sz="2100" dirty="0"/>
+            <a:endParaRPr lang="en-US" sz="2200" dirty="0"/>
           </a:p>
         </p:txBody>
       </p:sp>
@@ -9745,8 +11271,8 @@
         </p:nvSpPr>
         <p:spPr>
           <a:xfrm>
-            <a:off x="4399178" y="1965960"/>
-            <a:ext cx="3393338" cy="3749040"/>
+            <a:off x="4399178" y="2063496"/>
+            <a:ext cx="3393338" cy="3919728"/>
           </a:xfrm>
           <a:prstGeom prst="roundRect">
             <a:avLst>
@@ -9779,7 +11305,7 @@
         </p:nvSpPr>
         <p:spPr>
           <a:xfrm>
-            <a:off x="4527194" y="1965960"/>
+            <a:off x="4527194" y="2063496"/>
             <a:ext cx="3137306" cy="91440"/>
           </a:xfrm>
           <a:prstGeom prst="rect">
@@ -9804,7 +11330,7 @@
         </p:nvSpPr>
         <p:spPr>
           <a:xfrm>
-            <a:off x="4719218" y="2331720"/>
+            <a:off x="4719218" y="2429256"/>
             <a:ext cx="731520" cy="731520"/>
           </a:xfrm>
           <a:prstGeom prst="ellipse">
@@ -9829,7 +11355,7 @@
         </p:nvSpPr>
         <p:spPr>
           <a:xfrm>
-            <a:off x="4719218" y="2331720"/>
+            <a:off x="4719218" y="2429256"/>
             <a:ext cx="731520" cy="731520"/>
           </a:xfrm>
           <a:prstGeom prst="rect">
@@ -9868,8 +11394,8 @@
         </p:nvSpPr>
         <p:spPr>
           <a:xfrm>
-            <a:off x="4719218" y="3246120"/>
-            <a:ext cx="2753258" cy="2286000"/>
+            <a:off x="4719218" y="3343656"/>
+            <a:ext cx="2753258" cy="2456688"/>
           </a:xfrm>
           <a:prstGeom prst="rect">
             <a:avLst/>
@@ -9885,7 +11411,7 @@
               <a:buNone/>
             </a:pPr>
             <a:r>
-              <a:rPr lang="en-US" sz="2100" dirty="0">
+              <a:rPr lang="en-US" sz="2200" dirty="0">
                 <a:solidFill>
                   <a:srgbClr val="3C3828"/>
                 </a:solidFill>
@@ -9896,7 +11422,7 @@
               <a:t>Because writing is one of the most effective ways of </a:t>
             </a:r>
             <a:r>
-              <a:rPr lang="en-US" sz="2100" dirty="0">
+              <a:rPr lang="en-US" sz="2200" dirty="0">
                 <a:solidFill>
                   <a:srgbClr val="3C3828"/>
                 </a:solidFill>
@@ -9910,7 +11436,7 @@
               <a:t>expressing ourselves.</a:t>
             </a:r>
             <a:r>
-              <a:rPr lang="en-US" sz="2100" dirty="0">
+              <a:rPr lang="en-US" sz="2200" dirty="0">
                 <a:solidFill>
                   <a:srgbClr val="3C3828"/>
                 </a:solidFill>
@@ -9920,7 +11446,7 @@
               </a:rPr>
               <a:t> (What other ways can we express ourselves?)</a:t>
             </a:r>
-            <a:endParaRPr lang="en-US" sz="2100" dirty="0"/>
+            <a:endParaRPr lang="en-US" sz="2200" dirty="0"/>
           </a:p>
         </p:txBody>
       </p:sp>
@@ -9932,8 +11458,8 @@
         </p:nvSpPr>
         <p:spPr>
           <a:xfrm>
-            <a:off x="8112557" y="1965960"/>
-            <a:ext cx="3393338" cy="3749040"/>
+            <a:off x="8112557" y="2063496"/>
+            <a:ext cx="3393338" cy="3919728"/>
           </a:xfrm>
           <a:prstGeom prst="roundRect">
             <a:avLst>
@@ -9966,7 +11492,7 @@
         </p:nvSpPr>
         <p:spPr>
           <a:xfrm>
-            <a:off x="8240573" y="1965960"/>
+            <a:off x="8240573" y="2063496"/>
             <a:ext cx="3137306" cy="91440"/>
           </a:xfrm>
           <a:prstGeom prst="rect">
@@ -9991,7 +11517,7 @@
         </p:nvSpPr>
         <p:spPr>
           <a:xfrm>
-            <a:off x="8432597" y="2331720"/>
+            <a:off x="8432597" y="2429256"/>
             <a:ext cx="731520" cy="731520"/>
           </a:xfrm>
           <a:prstGeom prst="ellipse">
@@ -10016,7 +11542,7 @@
         </p:nvSpPr>
         <p:spPr>
           <a:xfrm>
-            <a:off x="8432597" y="2331720"/>
+            <a:off x="8432597" y="2429256"/>
             <a:ext cx="731520" cy="731520"/>
           </a:xfrm>
           <a:prstGeom prst="rect">
@@ -10055,8 +11581,8 @@
         </p:nvSpPr>
         <p:spPr>
           <a:xfrm>
-            <a:off x="8432597" y="3246120"/>
-            <a:ext cx="2753258" cy="2286000"/>
+            <a:off x="8432597" y="3343656"/>
+            <a:ext cx="2753258" cy="2456688"/>
           </a:xfrm>
           <a:prstGeom prst="rect">
             <a:avLst/>
@@ -10072,7 +11598,7 @@
               <a:buNone/>
             </a:pPr>
             <a:r>
-              <a:rPr lang="en-US" sz="2100" dirty="0">
+              <a:rPr lang="en-US" sz="2200" dirty="0">
                 <a:solidFill>
                   <a:srgbClr val="3C3828"/>
                 </a:solidFill>
@@ -10083,7 +11609,7 @@
               <a:t>Because </a:t>
             </a:r>
             <a:r>
-              <a:rPr lang="en-US" sz="2100" dirty="0">
+              <a:rPr lang="en-US" sz="2200" dirty="0">
                 <a:solidFill>
                   <a:srgbClr val="3C3828"/>
                 </a:solidFill>
@@ -10096,7 +11622,7 @@
               </a:rPr>
               <a:t>writing is power.</a:t>
             </a:r>
-            <a:endParaRPr lang="en-US" sz="2100" dirty="0"/>
+            <a:endParaRPr lang="en-US" sz="2200" dirty="0"/>
           </a:p>
         </p:txBody>
       </p:sp>
@@ -10287,7 +11813,7 @@
                 <a:ea typeface="Georgia" pitchFamily="34" charset="-122"/>
                 <a:cs typeface="Georgia" pitchFamily="34" charset="-120"/>
               </a:rPr>
-              <a:t>“Bored in the USA”</a:t>
+              <a:t>“Bored in the USA”</a:t>
             </a:r>
             <a:endParaRPr lang="en-US" sz="4000" dirty="0"/>
           </a:p>

</xml_diff>

<commit_message>
Drop decorative caps labels above headings, and say so in AGENTS.md
Brian: the small letter-spaced caps line over a title is a tell of
AI-generated design and rarely says anything. Removed where it restated the
heading: the How it works guides (Lesson Planner, Reporter, assignment
types), Terms, Privacy, Accessibility, and the admin free-tier notice; the
Lounge's Pinned label and 'Ask Brian' heading are plain text now. The
Thesis-Driven Essay decks keep their labels (Warm-up, Your turn, Step 4:
real cues) but draw them in sentence case, not caps; decks and scenes
rebuilt, lesson plans and handouts unchanged. AGENTS.md gains the rule so
no agent adds them back.

Co-Authored-By: Claude Opus 5.5 <noreply@anthropic.com>
Claude-Session: https://claude.ai/code/session_01UWebP7SAsMmN58YLrvovHd
</commit_message>
<xml_diff>
--- a/services/web-app/resources/thesis-essay-decks/lesson-1-day-1.pptx
+++ b/services/web-app/resources/thesis-essay-decks/lesson-1-day-1.pptx
@@ -2803,7 +2803,7 @@
               <a:buNone/>
             </a:pPr>
             <a:r>
-              <a:rPr lang="en-US" sz="1300" b="1" spc="200" kern="0" dirty="0">
+              <a:rPr lang="en-US" sz="1300" b="1" dirty="0">
                 <a:solidFill>
                   <a:srgbClr val="02BDC7"/>
                 </a:solidFill>
@@ -2811,7 +2811,7 @@
                 <a:ea typeface="Consolas" pitchFamily="34" charset="-122"/>
                 <a:cs typeface="Consolas" pitchFamily="34" charset="-120"/>
               </a:rPr>
-              <a:t>THESIS-DRIVEN ESSAY · LESSON 1</a:t>
+              <a:t>Thesis-Driven Essay · Lesson 1</a:t>
             </a:r>
             <a:endParaRPr lang="en-US" sz="1300" dirty="0"/>
           </a:p>
@@ -3121,7 +3121,7 @@
               <a:buNone/>
             </a:pPr>
             <a:r>
-              <a:rPr lang="en-US" sz="1200" b="1" spc="200" kern="0" dirty="0">
+              <a:rPr lang="en-US" sz="1200" b="1" dirty="0">
                 <a:solidFill>
                   <a:srgbClr val="02BDC7"/>
                 </a:solidFill>
@@ -3129,7 +3129,7 @@
                 <a:ea typeface="Consolas" pitchFamily="34" charset="-122"/>
                 <a:cs typeface="Consolas" pitchFamily="34" charset="-120"/>
               </a:rPr>
-              <a:t>CLASS DISCUSSION</a:t>
+              <a:t>Class discussion</a:t>
             </a:r>
             <a:endParaRPr lang="en-US" sz="1200" dirty="0"/>
           </a:p>
@@ -3871,7 +3871,7 @@
               <a:buNone/>
             </a:pPr>
             <a:r>
-              <a:rPr lang="en-US" sz="1200" b="1" spc="200" kern="0" dirty="0">
+              <a:rPr lang="en-US" sz="1200" b="1" dirty="0">
                 <a:solidFill>
                   <a:srgbClr val="02BDC7"/>
                 </a:solidFill>
@@ -3879,7 +3879,7 @@
                 <a:ea typeface="Consolas" pitchFamily="34" charset="-122"/>
                 <a:cs typeface="Consolas" pitchFamily="34" charset="-120"/>
               </a:rPr>
-              <a:t>THE FORM</a:t>
+              <a:t>The form</a:t>
             </a:r>
             <a:endParaRPr lang="en-US" sz="1200" dirty="0"/>
           </a:p>
@@ -4818,7 +4818,7 @@
               <a:buNone/>
             </a:pPr>
             <a:r>
-              <a:rPr lang="en-US" sz="1200" b="1" spc="200" kern="0" dirty="0">
+              <a:rPr lang="en-US" sz="1200" b="1" dirty="0">
                 <a:solidFill>
                   <a:srgbClr val="FF9755"/>
                 </a:solidFill>
@@ -4826,7 +4826,7 @@
                 <a:ea typeface="Consolas" pitchFamily="34" charset="-122"/>
                 <a:cs typeface="Consolas" pitchFamily="34" charset="-120"/>
               </a:rPr>
-              <a:t>WHY WE’RE HERE</a:t>
+              <a:t>Why we’re here</a:t>
             </a:r>
             <a:endParaRPr lang="en-US" sz="1200" dirty="0"/>
           </a:p>
@@ -5618,7 +5618,7 @@
               <a:buNone/>
             </a:pPr>
             <a:r>
-              <a:rPr lang="en-US" sz="1200" b="1" spc="200" kern="0" dirty="0">
+              <a:rPr lang="en-US" sz="1200" b="1" dirty="0">
                 <a:solidFill>
                   <a:srgbClr val="02BDC7"/>
                 </a:solidFill>
@@ -5626,7 +5626,7 @@
                 <a:ea typeface="Consolas" pitchFamily="34" charset="-122"/>
                 <a:cs typeface="Consolas" pitchFamily="34" charset="-120"/>
               </a:rPr>
-              <a:t>GET EVERYONE IN</a:t>
+              <a:t>Get everyone in</a:t>
             </a:r>
             <a:endParaRPr lang="en-US" sz="1200" dirty="0"/>
           </a:p>
@@ -6413,7 +6413,7 @@
               <a:buNone/>
             </a:pPr>
             <a:r>
-              <a:rPr lang="en-US" sz="1200" b="1" spc="200" kern="0" dirty="0">
+              <a:rPr lang="en-US" sz="1200" b="1" dirty="0">
                 <a:solidFill>
                   <a:srgbClr val="FFB600"/>
                 </a:solidFill>
@@ -6421,7 +6421,7 @@
                 <a:ea typeface="Consolas" pitchFamily="34" charset="-122"/>
                 <a:cs typeface="Consolas" pitchFamily="34" charset="-120"/>
               </a:rPr>
-              <a:t>FOR STUDENTS</a:t>
+              <a:t>For students</a:t>
             </a:r>
             <a:endParaRPr lang="en-US" sz="1200" dirty="0"/>
           </a:p>
@@ -7410,7 +7410,7 @@
               <a:buNone/>
             </a:pPr>
             <a:r>
-              <a:rPr lang="en-US" sz="1200" b="1" spc="200" kern="0" dirty="0">
+              <a:rPr lang="en-US" sz="1200" b="1" dirty="0">
                 <a:solidFill>
                   <a:srgbClr val="FC4540"/>
                 </a:solidFill>
@@ -7418,7 +7418,7 @@
                 <a:ea typeface="Consolas" pitchFamily="34" charset="-122"/>
                 <a:cs typeface="Consolas" pitchFamily="34" charset="-120"/>
               </a:rPr>
-              <a:t>YOU’RE IN</a:t>
+              <a:t>You’re in</a:t>
             </a:r>
             <a:endParaRPr lang="en-US" sz="1200" dirty="0"/>
           </a:p>
@@ -8401,7 +8401,7 @@
               <a:buNone/>
             </a:pPr>
             <a:r>
-              <a:rPr lang="en-US" sz="1200" b="1" spc="200" kern="0" dirty="0">
+              <a:rPr lang="en-US" sz="1200" b="1" dirty="0">
                 <a:solidFill>
                   <a:srgbClr val="02BDC7"/>
                 </a:solidFill>
@@ -8409,7 +8409,7 @@
                 <a:ea typeface="Consolas" pitchFamily="34" charset="-122"/>
                 <a:cs typeface="Consolas" pitchFamily="34" charset="-120"/>
               </a:rPr>
-              <a:t>2 TRUTHS AND A LIE</a:t>
+              <a:t>2 Truths and a Lie</a:t>
             </a:r>
             <a:endParaRPr lang="en-US" sz="1200" dirty="0"/>
           </a:p>
@@ -9226,7 +9226,7 @@
               <a:buNone/>
             </a:pPr>
             <a:r>
-              <a:rPr lang="en-US" sz="1200" b="1" spc="200" kern="0" dirty="0">
+              <a:rPr lang="en-US" sz="1200" b="1" dirty="0">
                 <a:solidFill>
                   <a:srgbClr val="02BDC7"/>
                 </a:solidFill>
@@ -9234,7 +9234,7 @@
                 <a:ea typeface="Consolas" pitchFamily="34" charset="-122"/>
                 <a:cs typeface="Consolas" pitchFamily="34" charset="-120"/>
               </a:rPr>
-              <a:t>THE REVEAL</a:t>
+              <a:t>The reveal</a:t>
             </a:r>
             <a:endParaRPr lang="en-US" sz="1200" dirty="0"/>
           </a:p>
@@ -9480,7 +9480,7 @@
               <a:buNone/>
             </a:pPr>
             <a:r>
-              <a:rPr lang="en-US" sz="1200" b="1" spc="200" kern="0" dirty="0">
+              <a:rPr lang="en-US" sz="1200" b="1" dirty="0">
                 <a:solidFill>
                   <a:srgbClr val="FFB600"/>
                 </a:solidFill>
@@ -9488,7 +9488,7 @@
                 <a:ea typeface="Consolas" pitchFamily="34" charset="-122"/>
                 <a:cs typeface="Consolas" pitchFamily="34" charset="-120"/>
               </a:rPr>
-              <a:t>THE REVEAL</a:t>
+              <a:t>The reveal</a:t>
             </a:r>
             <a:endParaRPr lang="en-US" sz="1200" dirty="0"/>
           </a:p>
@@ -9734,7 +9734,7 @@
               <a:buNone/>
             </a:pPr>
             <a:r>
-              <a:rPr lang="en-US" sz="1200" b="1" spc="200" kern="0" dirty="0">
+              <a:rPr lang="en-US" sz="1200" b="1" dirty="0">
                 <a:solidFill>
                   <a:srgbClr val="FC4540"/>
                 </a:solidFill>
@@ -9742,7 +9742,7 @@
                 <a:ea typeface="Consolas" pitchFamily="34" charset="-122"/>
                 <a:cs typeface="Consolas" pitchFamily="34" charset="-120"/>
               </a:rPr>
-              <a:t>2 TRUTHS AND A LIE</a:t>
+              <a:t>2 Truths and a Lie</a:t>
             </a:r>
             <a:endParaRPr lang="en-US" sz="1200" dirty="0"/>
           </a:p>
@@ -10594,7 +10594,7 @@
               <a:buNone/>
             </a:pPr>
             <a:r>
-              <a:rPr lang="en-US" sz="1200" b="1" spc="200" kern="0" dirty="0">
+              <a:rPr lang="en-US" sz="1200" b="1" dirty="0">
                 <a:solidFill>
                   <a:srgbClr val="FFB600"/>
                 </a:solidFill>
@@ -10602,7 +10602,7 @@
                 <a:ea typeface="Consolas" pitchFamily="34" charset="-122"/>
                 <a:cs typeface="Consolas" pitchFamily="34" charset="-120"/>
               </a:rPr>
-              <a:t>WALT WHITMAN</a:t>
+              <a:t>Walt Whitman</a:t>
             </a:r>
             <a:endParaRPr lang="en-US" sz="1200" dirty="0"/>
           </a:p>
@@ -10924,7 +10924,7 @@
               <a:buNone/>
             </a:pPr>
             <a:r>
-              <a:rPr lang="en-US" sz="1200" b="1" spc="200" kern="0" dirty="0">
+              <a:rPr lang="en-US" sz="1200" b="1" dirty="0">
                 <a:solidFill>
                   <a:srgbClr val="FC4540"/>
                 </a:solidFill>
@@ -10932,7 +10932,7 @@
                 <a:ea typeface="Consolas" pitchFamily="34" charset="-122"/>
                 <a:cs typeface="Consolas" pitchFamily="34" charset="-120"/>
               </a:rPr>
-              <a:t>WHY DO WE WRITE?</a:t>
+              <a:t>Why do we write?</a:t>
             </a:r>
             <a:endParaRPr lang="en-US" sz="1200" dirty="0"/>
           </a:p>

</xml_diff>